<commit_message>
docs: refine NA technical diagrams and improve presentation contrast
</commit_message>
<xml_diff>
--- a/docs/ppt/Volcano_KubeCon_NA_2026.pptx
+++ b/docs/ppt/Volcano_KubeCon_NA_2026.pptx
@@ -5558,7 +5558,7 @@
               </a:spcAft>
               <a:defRPr sz="1100" b="1">
                 <a:solidFill>
-                  <a:srgbClr val="356696"/>
+                  <a:srgbClr val="164F89"/>
                 </a:solidFill>
                 <a:latin typeface="Liberation Sans"/>
               </a:defRPr>
@@ -5597,7 +5597,7 @@
               </a:spcAft>
               <a:defRPr sz="4300" b="1">
                 <a:solidFill>
-                  <a:srgbClr val="202D3C"/>
+                  <a:srgbClr val="17283B"/>
                 </a:solidFill>
                 <a:latin typeface="Liberation Sans"/>
               </a:defRPr>
@@ -5613,7 +5613,7 @@
               </a:spcAft>
               <a:defRPr sz="4300" b="1">
                 <a:solidFill>
-                  <a:srgbClr val="202D3C"/>
+                  <a:srgbClr val="17283B"/>
                 </a:solidFill>
                 <a:latin typeface="Liberation Sans"/>
               </a:defRPr>
@@ -5652,7 +5652,7 @@
               </a:spcAft>
               <a:defRPr sz="3100" b="0">
                 <a:solidFill>
-                  <a:srgbClr val="356696"/>
+                  <a:srgbClr val="164F89"/>
                 </a:solidFill>
                 <a:latin typeface="Liberation Sans"/>
               </a:defRPr>
@@ -5668,7 +5668,7 @@
               </a:spcAft>
               <a:defRPr sz="3100" b="0">
                 <a:solidFill>
-                  <a:srgbClr val="356696"/>
+                  <a:srgbClr val="164F89"/>
                 </a:solidFill>
                 <a:latin typeface="Liberation Sans"/>
               </a:defRPr>
@@ -5707,7 +5707,7 @@
               </a:spcAft>
               <a:defRPr sz="2500" b="1">
                 <a:solidFill>
-                  <a:srgbClr val="202D3C"/>
+                  <a:srgbClr val="17283B"/>
                 </a:solidFill>
                 <a:latin typeface="Liberation Sans"/>
               </a:defRPr>
@@ -5746,7 +5746,7 @@
               </a:spcAft>
               <a:defRPr sz="1800" b="0">
                 <a:solidFill>
-                  <a:srgbClr val="647282"/>
+                  <a:srgbClr val="414F60"/>
                 </a:solidFill>
                 <a:latin typeface="Liberation Sans"/>
               </a:defRPr>
@@ -5762,7 +5762,7 @@
               </a:spcAft>
               <a:defRPr sz="1800" b="0">
                 <a:solidFill>
-                  <a:srgbClr val="647282"/>
+                  <a:srgbClr val="414F60"/>
                 </a:solidFill>
                 <a:latin typeface="Liberation Sans"/>
               </a:defRPr>
@@ -5801,7 +5801,7 @@
               </a:spcAft>
               <a:defRPr sz="900" b="0">
                 <a:solidFill>
-                  <a:srgbClr val="647282"/>
+                  <a:srgbClr val="414F60"/>
                 </a:solidFill>
                 <a:latin typeface="Liberation Sans"/>
               </a:defRPr>
@@ -5840,7 +5840,7 @@
               </a:spcAft>
               <a:defRPr sz="1100" b="0">
                 <a:solidFill>
-                  <a:srgbClr val="647282"/>
+                  <a:srgbClr val="414F60"/>
                 </a:solidFill>
                 <a:latin typeface="Liberation Sans"/>
               </a:defRPr>
@@ -5945,7 +5945,7 @@
               </a:spcAft>
               <a:defRPr sz="1100" b="1">
                 <a:solidFill>
-                  <a:srgbClr val="356696"/>
+                  <a:srgbClr val="164F89"/>
                 </a:solidFill>
                 <a:latin typeface="Liberation Sans"/>
               </a:defRPr>
@@ -5984,7 +5984,7 @@
               </a:spcAft>
               <a:defRPr sz="3100" b="1">
                 <a:solidFill>
-                  <a:srgbClr val="202D3C"/>
+                  <a:srgbClr val="17283B"/>
                 </a:solidFill>
                 <a:latin typeface="Liberation Sans"/>
               </a:defRPr>
@@ -6023,7 +6023,7 @@
               </a:spcAft>
               <a:defRPr sz="1700" b="0">
                 <a:solidFill>
-                  <a:srgbClr val="647282"/>
+                  <a:srgbClr val="414F60"/>
                 </a:solidFill>
                 <a:latin typeface="Liberation Sans"/>
               </a:defRPr>
@@ -6086,7 +6086,7 @@
               </a:spcAft>
               <a:defRPr sz="900" b="0">
                 <a:solidFill>
-                  <a:srgbClr val="647282"/>
+                  <a:srgbClr val="414F60"/>
                 </a:solidFill>
                 <a:latin typeface="Liberation Sans"/>
               </a:defRPr>
@@ -6125,7 +6125,7 @@
               </a:spcAft>
               <a:defRPr sz="1100" b="0">
                 <a:solidFill>
-                  <a:srgbClr val="647282"/>
+                  <a:srgbClr val="414F60"/>
                 </a:solidFill>
                 <a:latin typeface="Liberation Sans"/>
               </a:defRPr>
@@ -6230,7 +6230,7 @@
               </a:spcAft>
               <a:defRPr sz="1100" b="1">
                 <a:solidFill>
-                  <a:srgbClr val="356696"/>
+                  <a:srgbClr val="164F89"/>
                 </a:solidFill>
                 <a:latin typeface="Liberation Sans"/>
               </a:defRPr>
@@ -6269,7 +6269,7 @@
               </a:spcAft>
               <a:defRPr sz="3100" b="1">
                 <a:solidFill>
-                  <a:srgbClr val="202D3C"/>
+                  <a:srgbClr val="17283B"/>
                 </a:solidFill>
                 <a:latin typeface="Liberation Sans"/>
               </a:defRPr>
@@ -6308,7 +6308,7 @@
               </a:spcAft>
               <a:defRPr sz="1700" b="0">
                 <a:solidFill>
-                  <a:srgbClr val="647282"/>
+                  <a:srgbClr val="414F60"/>
                 </a:solidFill>
                 <a:latin typeface="Liberation Sans"/>
               </a:defRPr>
@@ -6371,7 +6371,7 @@
               </a:spcAft>
               <a:defRPr sz="900" b="0">
                 <a:solidFill>
-                  <a:srgbClr val="647282"/>
+                  <a:srgbClr val="414F60"/>
                 </a:solidFill>
                 <a:latin typeface="Liberation Sans"/>
               </a:defRPr>
@@ -6410,7 +6410,7 @@
               </a:spcAft>
               <a:defRPr sz="1100" b="0">
                 <a:solidFill>
-                  <a:srgbClr val="647282"/>
+                  <a:srgbClr val="414F60"/>
                 </a:solidFill>
                 <a:latin typeface="Liberation Sans"/>
               </a:defRPr>
@@ -6515,7 +6515,7 @@
               </a:spcAft>
               <a:defRPr sz="1100" b="1">
                 <a:solidFill>
-                  <a:srgbClr val="356696"/>
+                  <a:srgbClr val="164F89"/>
                 </a:solidFill>
                 <a:latin typeface="Liberation Sans"/>
               </a:defRPr>
@@ -6554,7 +6554,7 @@
               </a:spcAft>
               <a:defRPr sz="3800" b="1">
                 <a:solidFill>
-                  <a:srgbClr val="356696"/>
+                  <a:srgbClr val="164F89"/>
                 </a:solidFill>
                 <a:latin typeface="Liberation Sans"/>
               </a:defRPr>
@@ -6593,7 +6593,7 @@
               </a:spcAft>
               <a:defRPr sz="4100" b="1">
                 <a:solidFill>
-                  <a:srgbClr val="202D3C"/>
+                  <a:srgbClr val="17283B"/>
                 </a:solidFill>
                 <a:latin typeface="Liberation Sans"/>
               </a:defRPr>
@@ -6632,7 +6632,7 @@
               </a:spcAft>
               <a:defRPr sz="2400" b="0">
                 <a:solidFill>
-                  <a:srgbClr val="356696"/>
+                  <a:srgbClr val="164F89"/>
                 </a:solidFill>
                 <a:latin typeface="Liberation Sans"/>
               </a:defRPr>
@@ -6671,7 +6671,7 @@
               </a:spcAft>
               <a:defRPr sz="2100" b="0">
                 <a:solidFill>
-                  <a:srgbClr val="647282"/>
+                  <a:srgbClr val="414F60"/>
                 </a:solidFill>
                 <a:latin typeface="Liberation Sans"/>
               </a:defRPr>
@@ -6710,7 +6710,7 @@
               </a:spcAft>
               <a:defRPr sz="1500" b="0">
                 <a:solidFill>
-                  <a:srgbClr val="647282"/>
+                  <a:srgbClr val="414F60"/>
                 </a:solidFill>
                 <a:latin typeface="Liberation Sans"/>
               </a:defRPr>
@@ -6749,7 +6749,7 @@
               </a:spcAft>
               <a:defRPr sz="1500" b="0">
                 <a:solidFill>
-                  <a:srgbClr val="647282"/>
+                  <a:srgbClr val="414F60"/>
                 </a:solidFill>
                 <a:latin typeface="Liberation Sans"/>
               </a:defRPr>
@@ -6788,7 +6788,7 @@
               </a:spcAft>
               <a:defRPr sz="1500" b="1">
                 <a:solidFill>
-                  <a:srgbClr val="356696"/>
+                  <a:srgbClr val="164F89"/>
                 </a:solidFill>
                 <a:latin typeface="Liberation Sans"/>
               </a:defRPr>
@@ -6827,7 +6827,7 @@
               </a:spcAft>
               <a:defRPr sz="1500" b="0">
                 <a:solidFill>
-                  <a:srgbClr val="647282"/>
+                  <a:srgbClr val="414F60"/>
                 </a:solidFill>
                 <a:latin typeface="Liberation Sans"/>
               </a:defRPr>
@@ -6866,7 +6866,7 @@
               </a:spcAft>
               <a:defRPr sz="900" b="0">
                 <a:solidFill>
-                  <a:srgbClr val="647282"/>
+                  <a:srgbClr val="414F60"/>
                 </a:solidFill>
                 <a:latin typeface="Liberation Sans"/>
               </a:defRPr>
@@ -6905,7 +6905,7 @@
               </a:spcAft>
               <a:defRPr sz="1100" b="0">
                 <a:solidFill>
-                  <a:srgbClr val="647282"/>
+                  <a:srgbClr val="414F60"/>
                 </a:solidFill>
                 <a:latin typeface="Liberation Sans"/>
               </a:defRPr>
@@ -7010,7 +7010,7 @@
               </a:spcAft>
               <a:defRPr sz="1100" b="1">
                 <a:solidFill>
-                  <a:srgbClr val="356696"/>
+                  <a:srgbClr val="164F89"/>
                 </a:solidFill>
                 <a:latin typeface="Liberation Sans"/>
               </a:defRPr>
@@ -7049,7 +7049,7 @@
               </a:spcAft>
               <a:defRPr sz="3100" b="1">
                 <a:solidFill>
-                  <a:srgbClr val="202D3C"/>
+                  <a:srgbClr val="17283B"/>
                 </a:solidFill>
                 <a:latin typeface="Liberation Sans"/>
               </a:defRPr>
@@ -7088,7 +7088,7 @@
               </a:spcAft>
               <a:defRPr sz="1700" b="0">
                 <a:solidFill>
-                  <a:srgbClr val="647282"/>
+                  <a:srgbClr val="414F60"/>
                 </a:solidFill>
                 <a:latin typeface="Liberation Sans"/>
               </a:defRPr>
@@ -7151,7 +7151,7 @@
               </a:spcAft>
               <a:defRPr sz="900" b="0">
                 <a:solidFill>
-                  <a:srgbClr val="647282"/>
+                  <a:srgbClr val="414F60"/>
                 </a:solidFill>
                 <a:latin typeface="Liberation Sans"/>
               </a:defRPr>
@@ -7190,7 +7190,7 @@
               </a:spcAft>
               <a:defRPr sz="1100" b="0">
                 <a:solidFill>
-                  <a:srgbClr val="647282"/>
+                  <a:srgbClr val="414F60"/>
                 </a:solidFill>
                 <a:latin typeface="Liberation Sans"/>
               </a:defRPr>
@@ -7295,7 +7295,7 @@
               </a:spcAft>
               <a:defRPr sz="1100" b="1">
                 <a:solidFill>
-                  <a:srgbClr val="356696"/>
+                  <a:srgbClr val="164F89"/>
                 </a:solidFill>
                 <a:latin typeface="Liberation Sans"/>
               </a:defRPr>
@@ -7334,7 +7334,7 @@
               </a:spcAft>
               <a:defRPr sz="3100" b="1">
                 <a:solidFill>
-                  <a:srgbClr val="202D3C"/>
+                  <a:srgbClr val="17283B"/>
                 </a:solidFill>
                 <a:latin typeface="Liberation Sans"/>
               </a:defRPr>
@@ -7373,7 +7373,7 @@
               </a:spcAft>
               <a:defRPr sz="1700" b="0">
                 <a:solidFill>
-                  <a:srgbClr val="647282"/>
+                  <a:srgbClr val="414F60"/>
                 </a:solidFill>
                 <a:latin typeface="Liberation Sans"/>
               </a:defRPr>
@@ -7436,7 +7436,7 @@
               </a:spcAft>
               <a:defRPr sz="900" b="0">
                 <a:solidFill>
-                  <a:srgbClr val="647282"/>
+                  <a:srgbClr val="414F60"/>
                 </a:solidFill>
                 <a:latin typeface="Liberation Sans"/>
               </a:defRPr>
@@ -7475,7 +7475,7 @@
               </a:spcAft>
               <a:defRPr sz="1100" b="0">
                 <a:solidFill>
-                  <a:srgbClr val="647282"/>
+                  <a:srgbClr val="414F60"/>
                 </a:solidFill>
                 <a:latin typeface="Liberation Sans"/>
               </a:defRPr>
@@ -7580,7 +7580,7 @@
               </a:spcAft>
               <a:defRPr sz="1100" b="1">
                 <a:solidFill>
-                  <a:srgbClr val="356696"/>
+                  <a:srgbClr val="164F89"/>
                 </a:solidFill>
                 <a:latin typeface="Liberation Sans"/>
               </a:defRPr>
@@ -7619,7 +7619,7 @@
               </a:spcAft>
               <a:defRPr sz="3100" b="1">
                 <a:solidFill>
-                  <a:srgbClr val="202D3C"/>
+                  <a:srgbClr val="17283B"/>
                 </a:solidFill>
                 <a:latin typeface="Liberation Sans"/>
               </a:defRPr>
@@ -7658,7 +7658,7 @@
               </a:spcAft>
               <a:defRPr sz="1700" b="0">
                 <a:solidFill>
-                  <a:srgbClr val="647282"/>
+                  <a:srgbClr val="414F60"/>
                 </a:solidFill>
                 <a:latin typeface="Liberation Sans"/>
               </a:defRPr>
@@ -7721,7 +7721,7 @@
               </a:spcAft>
               <a:defRPr sz="900" b="0">
                 <a:solidFill>
-                  <a:srgbClr val="647282"/>
+                  <a:srgbClr val="414F60"/>
                 </a:solidFill>
                 <a:latin typeface="Liberation Sans"/>
               </a:defRPr>
@@ -7760,7 +7760,7 @@
               </a:spcAft>
               <a:defRPr sz="1100" b="0">
                 <a:solidFill>
-                  <a:srgbClr val="647282"/>
+                  <a:srgbClr val="414F60"/>
                 </a:solidFill>
                 <a:latin typeface="Liberation Sans"/>
               </a:defRPr>
@@ -7865,7 +7865,7 @@
               </a:spcAft>
               <a:defRPr sz="1100" b="1">
                 <a:solidFill>
-                  <a:srgbClr val="356696"/>
+                  <a:srgbClr val="164F89"/>
                 </a:solidFill>
                 <a:latin typeface="Liberation Sans"/>
               </a:defRPr>
@@ -7904,7 +7904,7 @@
               </a:spcAft>
               <a:defRPr sz="3100" b="1">
                 <a:solidFill>
-                  <a:srgbClr val="202D3C"/>
+                  <a:srgbClr val="17283B"/>
                 </a:solidFill>
                 <a:latin typeface="Liberation Sans"/>
               </a:defRPr>
@@ -7943,7 +7943,7 @@
               </a:spcAft>
               <a:defRPr sz="1700" b="0">
                 <a:solidFill>
-                  <a:srgbClr val="647282"/>
+                  <a:srgbClr val="414F60"/>
                 </a:solidFill>
                 <a:latin typeface="Liberation Sans"/>
               </a:defRPr>
@@ -8006,7 +8006,7 @@
               </a:spcAft>
               <a:defRPr sz="900" b="0">
                 <a:solidFill>
-                  <a:srgbClr val="647282"/>
+                  <a:srgbClr val="414F60"/>
                 </a:solidFill>
                 <a:latin typeface="Liberation Sans"/>
               </a:defRPr>
@@ -8045,7 +8045,7 @@
               </a:spcAft>
               <a:defRPr sz="1100" b="0">
                 <a:solidFill>
-                  <a:srgbClr val="647282"/>
+                  <a:srgbClr val="414F60"/>
                 </a:solidFill>
                 <a:latin typeface="Liberation Sans"/>
               </a:defRPr>
@@ -8150,7 +8150,7 @@
               </a:spcAft>
               <a:defRPr sz="1100" b="1">
                 <a:solidFill>
-                  <a:srgbClr val="356696"/>
+                  <a:srgbClr val="164F89"/>
                 </a:solidFill>
                 <a:latin typeface="Liberation Sans"/>
               </a:defRPr>
@@ -8189,7 +8189,7 @@
               </a:spcAft>
               <a:defRPr sz="3800" b="1">
                 <a:solidFill>
-                  <a:srgbClr val="356696"/>
+                  <a:srgbClr val="164F89"/>
                 </a:solidFill>
                 <a:latin typeface="Liberation Sans"/>
               </a:defRPr>
@@ -8228,7 +8228,7 @@
               </a:spcAft>
               <a:defRPr sz="4100" b="1">
                 <a:solidFill>
-                  <a:srgbClr val="202D3C"/>
+                  <a:srgbClr val="17283B"/>
                 </a:solidFill>
                 <a:latin typeface="Liberation Sans"/>
               </a:defRPr>
@@ -8244,7 +8244,7 @@
               </a:spcAft>
               <a:defRPr sz="4100" b="1">
                 <a:solidFill>
-                  <a:srgbClr val="202D3C"/>
+                  <a:srgbClr val="17283B"/>
                 </a:solidFill>
                 <a:latin typeface="Liberation Sans"/>
               </a:defRPr>
@@ -8283,7 +8283,7 @@
               </a:spcAft>
               <a:defRPr sz="2400" b="0">
                 <a:solidFill>
-                  <a:srgbClr val="356696"/>
+                  <a:srgbClr val="164F89"/>
                 </a:solidFill>
                 <a:latin typeface="Liberation Sans"/>
               </a:defRPr>
@@ -8322,7 +8322,7 @@
               </a:spcAft>
               <a:defRPr sz="2100" b="0">
                 <a:solidFill>
-                  <a:srgbClr val="647282"/>
+                  <a:srgbClr val="414F60"/>
                 </a:solidFill>
                 <a:latin typeface="Liberation Sans"/>
               </a:defRPr>
@@ -8361,7 +8361,7 @@
               </a:spcAft>
               <a:defRPr sz="1500" b="0">
                 <a:solidFill>
-                  <a:srgbClr val="647282"/>
+                  <a:srgbClr val="414F60"/>
                 </a:solidFill>
                 <a:latin typeface="Liberation Sans"/>
               </a:defRPr>
@@ -8400,7 +8400,7 @@
               </a:spcAft>
               <a:defRPr sz="1500" b="0">
                 <a:solidFill>
-                  <a:srgbClr val="647282"/>
+                  <a:srgbClr val="414F60"/>
                 </a:solidFill>
                 <a:latin typeface="Liberation Sans"/>
               </a:defRPr>
@@ -8439,7 +8439,7 @@
               </a:spcAft>
               <a:defRPr sz="1500" b="0">
                 <a:solidFill>
-                  <a:srgbClr val="647282"/>
+                  <a:srgbClr val="414F60"/>
                 </a:solidFill>
                 <a:latin typeface="Liberation Sans"/>
               </a:defRPr>
@@ -8478,7 +8478,7 @@
               </a:spcAft>
               <a:defRPr sz="1500" b="1">
                 <a:solidFill>
-                  <a:srgbClr val="356696"/>
+                  <a:srgbClr val="164F89"/>
                 </a:solidFill>
                 <a:latin typeface="Liberation Sans"/>
               </a:defRPr>
@@ -8517,7 +8517,7 @@
               </a:spcAft>
               <a:defRPr sz="900" b="0">
                 <a:solidFill>
-                  <a:srgbClr val="647282"/>
+                  <a:srgbClr val="414F60"/>
                 </a:solidFill>
                 <a:latin typeface="Liberation Sans"/>
               </a:defRPr>
@@ -8556,7 +8556,7 @@
               </a:spcAft>
               <a:defRPr sz="1100" b="0">
                 <a:solidFill>
-                  <a:srgbClr val="647282"/>
+                  <a:srgbClr val="414F60"/>
                 </a:solidFill>
                 <a:latin typeface="Liberation Sans"/>
               </a:defRPr>
@@ -8661,7 +8661,7 @@
               </a:spcAft>
               <a:defRPr sz="1100" b="1">
                 <a:solidFill>
-                  <a:srgbClr val="356696"/>
+                  <a:srgbClr val="164F89"/>
                 </a:solidFill>
                 <a:latin typeface="Liberation Sans"/>
               </a:defRPr>
@@ -8700,7 +8700,7 @@
               </a:spcAft>
               <a:defRPr sz="3100" b="1">
                 <a:solidFill>
-                  <a:srgbClr val="202D3C"/>
+                  <a:srgbClr val="17283B"/>
                 </a:solidFill>
                 <a:latin typeface="Liberation Sans"/>
               </a:defRPr>
@@ -8739,7 +8739,7 @@
               </a:spcAft>
               <a:defRPr sz="1700" b="0">
                 <a:solidFill>
-                  <a:srgbClr val="647282"/>
+                  <a:srgbClr val="414F60"/>
                 </a:solidFill>
                 <a:latin typeface="Liberation Sans"/>
               </a:defRPr>
@@ -8802,7 +8802,7 @@
               </a:spcAft>
               <a:defRPr sz="900" b="0">
                 <a:solidFill>
-                  <a:srgbClr val="647282"/>
+                  <a:srgbClr val="414F60"/>
                 </a:solidFill>
                 <a:latin typeface="Liberation Sans"/>
               </a:defRPr>
@@ -8841,7 +8841,7 @@
               </a:spcAft>
               <a:defRPr sz="1100" b="0">
                 <a:solidFill>
-                  <a:srgbClr val="647282"/>
+                  <a:srgbClr val="414F60"/>
                 </a:solidFill>
                 <a:latin typeface="Liberation Sans"/>
               </a:defRPr>
@@ -8946,7 +8946,7 @@
               </a:spcAft>
               <a:defRPr sz="1100" b="1">
                 <a:solidFill>
-                  <a:srgbClr val="356696"/>
+                  <a:srgbClr val="164F89"/>
                 </a:solidFill>
                 <a:latin typeface="Liberation Sans"/>
               </a:defRPr>
@@ -8985,7 +8985,7 @@
               </a:spcAft>
               <a:defRPr sz="3100" b="1">
                 <a:solidFill>
-                  <a:srgbClr val="202D3C"/>
+                  <a:srgbClr val="17283B"/>
                 </a:solidFill>
                 <a:latin typeface="Liberation Sans"/>
               </a:defRPr>
@@ -9024,7 +9024,7 @@
               </a:spcAft>
               <a:defRPr sz="1700" b="0">
                 <a:solidFill>
-                  <a:srgbClr val="647282"/>
+                  <a:srgbClr val="414F60"/>
                 </a:solidFill>
                 <a:latin typeface="Liberation Sans"/>
               </a:defRPr>
@@ -9087,7 +9087,7 @@
               </a:spcAft>
               <a:defRPr sz="900" b="0">
                 <a:solidFill>
-                  <a:srgbClr val="647282"/>
+                  <a:srgbClr val="414F60"/>
                 </a:solidFill>
                 <a:latin typeface="Liberation Sans"/>
               </a:defRPr>
@@ -9126,7 +9126,7 @@
               </a:spcAft>
               <a:defRPr sz="1100" b="0">
                 <a:solidFill>
-                  <a:srgbClr val="647282"/>
+                  <a:srgbClr val="414F60"/>
                 </a:solidFill>
                 <a:latin typeface="Liberation Sans"/>
               </a:defRPr>
@@ -9231,7 +9231,7 @@
               </a:spcAft>
               <a:defRPr sz="1100" b="1">
                 <a:solidFill>
-                  <a:srgbClr val="356696"/>
+                  <a:srgbClr val="164F89"/>
                 </a:solidFill>
                 <a:latin typeface="Liberation Sans"/>
               </a:defRPr>
@@ -9270,7 +9270,7 @@
               </a:spcAft>
               <a:defRPr sz="3300" b="1">
                 <a:solidFill>
-                  <a:srgbClr val="202D3C"/>
+                  <a:srgbClr val="17283B"/>
                 </a:solidFill>
                 <a:latin typeface="Liberation Sans"/>
               </a:defRPr>
@@ -9333,7 +9333,7 @@
               </a:spcAft>
               <a:defRPr sz="3000" b="1">
                 <a:solidFill>
-                  <a:srgbClr val="202D3C"/>
+                  <a:srgbClr val="17283B"/>
                 </a:solidFill>
                 <a:latin typeface="Liberation Sans"/>
               </a:defRPr>
@@ -9372,7 +9372,7 @@
               </a:spcAft>
               <a:defRPr sz="2200" b="0">
                 <a:solidFill>
-                  <a:srgbClr val="356696"/>
+                  <a:srgbClr val="164F89"/>
                 </a:solidFill>
                 <a:latin typeface="Liberation Sans"/>
               </a:defRPr>
@@ -9411,7 +9411,7 @@
               </a:spcAft>
               <a:defRPr sz="2000" b="0">
                 <a:solidFill>
-                  <a:srgbClr val="647282"/>
+                  <a:srgbClr val="414F60"/>
                 </a:solidFill>
                 <a:latin typeface="Liberation Sans"/>
               </a:defRPr>
@@ -9427,7 +9427,7 @@
               </a:spcAft>
               <a:defRPr sz="2000" b="0">
                 <a:solidFill>
-                  <a:srgbClr val="647282"/>
+                  <a:srgbClr val="414F60"/>
                 </a:solidFill>
                 <a:latin typeface="Liberation Sans"/>
               </a:defRPr>
@@ -9466,7 +9466,7 @@
               </a:spcAft>
               <a:defRPr sz="1500" b="0">
                 <a:solidFill>
-                  <a:srgbClr val="356696"/>
+                  <a:srgbClr val="164F89"/>
                 </a:solidFill>
                 <a:latin typeface="Liberation Sans"/>
               </a:defRPr>
@@ -9529,7 +9529,7 @@
               </a:spcAft>
               <a:defRPr sz="3000" b="1">
                 <a:solidFill>
-                  <a:srgbClr val="202D3C"/>
+                  <a:srgbClr val="17283B"/>
                 </a:solidFill>
                 <a:latin typeface="Liberation Sans"/>
               </a:defRPr>
@@ -9568,7 +9568,7 @@
               </a:spcAft>
               <a:defRPr sz="2200" b="0">
                 <a:solidFill>
-                  <a:srgbClr val="356696"/>
+                  <a:srgbClr val="164F89"/>
                 </a:solidFill>
                 <a:latin typeface="Liberation Sans"/>
               </a:defRPr>
@@ -9607,7 +9607,7 @@
               </a:spcAft>
               <a:defRPr sz="2000" b="0">
                 <a:solidFill>
-                  <a:srgbClr val="647282"/>
+                  <a:srgbClr val="414F60"/>
                 </a:solidFill>
                 <a:latin typeface="Liberation Sans"/>
               </a:defRPr>
@@ -9623,7 +9623,7 @@
               </a:spcAft>
               <a:defRPr sz="2000" b="0">
                 <a:solidFill>
-                  <a:srgbClr val="647282"/>
+                  <a:srgbClr val="414F60"/>
                 </a:solidFill>
                 <a:latin typeface="Liberation Sans"/>
               </a:defRPr>
@@ -9662,7 +9662,7 @@
               </a:spcAft>
               <a:defRPr sz="1500" b="0">
                 <a:solidFill>
-                  <a:srgbClr val="356696"/>
+                  <a:srgbClr val="164F89"/>
                 </a:solidFill>
                 <a:latin typeface="Liberation Sans"/>
               </a:defRPr>
@@ -9701,7 +9701,7 @@
               </a:spcAft>
               <a:defRPr sz="900" b="0">
                 <a:solidFill>
-                  <a:srgbClr val="647282"/>
+                  <a:srgbClr val="414F60"/>
                 </a:solidFill>
                 <a:latin typeface="Liberation Sans"/>
               </a:defRPr>
@@ -9740,7 +9740,7 @@
               </a:spcAft>
               <a:defRPr sz="1100" b="0">
                 <a:solidFill>
-                  <a:srgbClr val="647282"/>
+                  <a:srgbClr val="414F60"/>
                 </a:solidFill>
                 <a:latin typeface="Liberation Sans"/>
               </a:defRPr>
@@ -9845,7 +9845,7 @@
               </a:spcAft>
               <a:defRPr sz="1100" b="1">
                 <a:solidFill>
-                  <a:srgbClr val="356696"/>
+                  <a:srgbClr val="164F89"/>
                 </a:solidFill>
                 <a:latin typeface="Liberation Sans"/>
               </a:defRPr>
@@ -9884,7 +9884,7 @@
               </a:spcAft>
               <a:defRPr sz="3100" b="1">
                 <a:solidFill>
-                  <a:srgbClr val="202D3C"/>
+                  <a:srgbClr val="17283B"/>
                 </a:solidFill>
                 <a:latin typeface="Liberation Sans"/>
               </a:defRPr>
@@ -9923,7 +9923,7 @@
               </a:spcAft>
               <a:defRPr sz="1700" b="0">
                 <a:solidFill>
-                  <a:srgbClr val="647282"/>
+                  <a:srgbClr val="414F60"/>
                 </a:solidFill>
                 <a:latin typeface="Liberation Sans"/>
               </a:defRPr>
@@ -9986,7 +9986,7 @@
               </a:spcAft>
               <a:defRPr sz="900" b="0">
                 <a:solidFill>
-                  <a:srgbClr val="647282"/>
+                  <a:srgbClr val="414F60"/>
                 </a:solidFill>
                 <a:latin typeface="Liberation Sans"/>
               </a:defRPr>
@@ -10025,7 +10025,7 @@
               </a:spcAft>
               <a:defRPr sz="1100" b="0">
                 <a:solidFill>
-                  <a:srgbClr val="647282"/>
+                  <a:srgbClr val="414F60"/>
                 </a:solidFill>
                 <a:latin typeface="Liberation Sans"/>
               </a:defRPr>
@@ -10130,7 +10130,7 @@
               </a:spcAft>
               <a:defRPr sz="1100" b="1">
                 <a:solidFill>
-                  <a:srgbClr val="356696"/>
+                  <a:srgbClr val="164F89"/>
                 </a:solidFill>
                 <a:latin typeface="Liberation Sans"/>
               </a:defRPr>
@@ -10169,7 +10169,7 @@
               </a:spcAft>
               <a:defRPr sz="3100" b="1">
                 <a:solidFill>
-                  <a:srgbClr val="202D3C"/>
+                  <a:srgbClr val="17283B"/>
                 </a:solidFill>
                 <a:latin typeface="Liberation Sans"/>
               </a:defRPr>
@@ -10208,7 +10208,7 @@
               </a:spcAft>
               <a:defRPr sz="1700" b="0">
                 <a:solidFill>
-                  <a:srgbClr val="647282"/>
+                  <a:srgbClr val="414F60"/>
                 </a:solidFill>
                 <a:latin typeface="Liberation Sans"/>
               </a:defRPr>
@@ -10271,7 +10271,7 @@
               </a:spcAft>
               <a:defRPr sz="900" b="0">
                 <a:solidFill>
-                  <a:srgbClr val="647282"/>
+                  <a:srgbClr val="414F60"/>
                 </a:solidFill>
                 <a:latin typeface="Liberation Sans"/>
               </a:defRPr>
@@ -10310,7 +10310,7 @@
               </a:spcAft>
               <a:defRPr sz="1100" b="0">
                 <a:solidFill>
-                  <a:srgbClr val="647282"/>
+                  <a:srgbClr val="414F60"/>
                 </a:solidFill>
                 <a:latin typeface="Liberation Sans"/>
               </a:defRPr>
@@ -10415,7 +10415,7 @@
               </a:spcAft>
               <a:defRPr sz="1100" b="1">
                 <a:solidFill>
-                  <a:srgbClr val="356696"/>
+                  <a:srgbClr val="164F89"/>
                 </a:solidFill>
                 <a:latin typeface="Liberation Sans"/>
               </a:defRPr>
@@ -10454,7 +10454,7 @@
               </a:spcAft>
               <a:defRPr sz="3100" b="1">
                 <a:solidFill>
-                  <a:srgbClr val="202D3C"/>
+                  <a:srgbClr val="17283B"/>
                 </a:solidFill>
                 <a:latin typeface="Liberation Sans"/>
               </a:defRPr>
@@ -10493,7 +10493,7 @@
               </a:spcAft>
               <a:defRPr sz="1700" b="0">
                 <a:solidFill>
-                  <a:srgbClr val="647282"/>
+                  <a:srgbClr val="414F60"/>
                 </a:solidFill>
                 <a:latin typeface="Liberation Sans"/>
               </a:defRPr>
@@ -10556,7 +10556,7 @@
               </a:spcAft>
               <a:defRPr sz="900" b="0">
                 <a:solidFill>
-                  <a:srgbClr val="647282"/>
+                  <a:srgbClr val="414F60"/>
                 </a:solidFill>
                 <a:latin typeface="Liberation Sans"/>
               </a:defRPr>
@@ -10595,7 +10595,7 @@
               </a:spcAft>
               <a:defRPr sz="1100" b="0">
                 <a:solidFill>
-                  <a:srgbClr val="647282"/>
+                  <a:srgbClr val="414F60"/>
                 </a:solidFill>
                 <a:latin typeface="Liberation Sans"/>
               </a:defRPr>
@@ -10700,7 +10700,7 @@
               </a:spcAft>
               <a:defRPr sz="1100" b="1">
                 <a:solidFill>
-                  <a:srgbClr val="356696"/>
+                  <a:srgbClr val="164F89"/>
                 </a:solidFill>
                 <a:latin typeface="Liberation Sans"/>
               </a:defRPr>
@@ -10739,7 +10739,7 @@
               </a:spcAft>
               <a:defRPr sz="3800" b="1">
                 <a:solidFill>
-                  <a:srgbClr val="356696"/>
+                  <a:srgbClr val="164F89"/>
                 </a:solidFill>
                 <a:latin typeface="Liberation Sans"/>
               </a:defRPr>
@@ -10778,7 +10778,7 @@
               </a:spcAft>
               <a:defRPr sz="4100" b="1">
                 <a:solidFill>
-                  <a:srgbClr val="202D3C"/>
+                  <a:srgbClr val="17283B"/>
                 </a:solidFill>
                 <a:latin typeface="Liberation Sans"/>
               </a:defRPr>
@@ -10817,7 +10817,7 @@
               </a:spcAft>
               <a:defRPr sz="2400" b="0">
                 <a:solidFill>
-                  <a:srgbClr val="356696"/>
+                  <a:srgbClr val="164F89"/>
                 </a:solidFill>
                 <a:latin typeface="Liberation Sans"/>
               </a:defRPr>
@@ -10856,7 +10856,7 @@
               </a:spcAft>
               <a:defRPr sz="2100" b="0">
                 <a:solidFill>
-                  <a:srgbClr val="647282"/>
+                  <a:srgbClr val="414F60"/>
                 </a:solidFill>
                 <a:latin typeface="Liberation Sans"/>
               </a:defRPr>
@@ -10895,7 +10895,7 @@
               </a:spcAft>
               <a:defRPr sz="1500" b="1">
                 <a:solidFill>
-                  <a:srgbClr val="356696"/>
+                  <a:srgbClr val="164F89"/>
                 </a:solidFill>
                 <a:latin typeface="Liberation Sans"/>
               </a:defRPr>
@@ -10934,7 +10934,7 @@
               </a:spcAft>
               <a:defRPr sz="1500" b="0">
                 <a:solidFill>
-                  <a:srgbClr val="647282"/>
+                  <a:srgbClr val="414F60"/>
                 </a:solidFill>
                 <a:latin typeface="Liberation Sans"/>
               </a:defRPr>
@@ -10973,7 +10973,7 @@
               </a:spcAft>
               <a:defRPr sz="1500" b="0">
                 <a:solidFill>
-                  <a:srgbClr val="647282"/>
+                  <a:srgbClr val="414F60"/>
                 </a:solidFill>
                 <a:latin typeface="Liberation Sans"/>
               </a:defRPr>
@@ -11012,7 +11012,7 @@
               </a:spcAft>
               <a:defRPr sz="1500" b="0">
                 <a:solidFill>
-                  <a:srgbClr val="647282"/>
+                  <a:srgbClr val="414F60"/>
                 </a:solidFill>
                 <a:latin typeface="Liberation Sans"/>
               </a:defRPr>
@@ -11051,7 +11051,7 @@
               </a:spcAft>
               <a:defRPr sz="900" b="0">
                 <a:solidFill>
-                  <a:srgbClr val="647282"/>
+                  <a:srgbClr val="414F60"/>
                 </a:solidFill>
                 <a:latin typeface="Liberation Sans"/>
               </a:defRPr>
@@ -11090,7 +11090,7 @@
               </a:spcAft>
               <a:defRPr sz="1100" b="0">
                 <a:solidFill>
-                  <a:srgbClr val="647282"/>
+                  <a:srgbClr val="414F60"/>
                 </a:solidFill>
                 <a:latin typeface="Liberation Sans"/>
               </a:defRPr>
@@ -11195,7 +11195,7 @@
               </a:spcAft>
               <a:defRPr sz="1100" b="1">
                 <a:solidFill>
-                  <a:srgbClr val="356696"/>
+                  <a:srgbClr val="164F89"/>
                 </a:solidFill>
                 <a:latin typeface="Liberation Sans"/>
               </a:defRPr>
@@ -11234,7 +11234,7 @@
               </a:spcAft>
               <a:defRPr sz="3100" b="1">
                 <a:solidFill>
-                  <a:srgbClr val="202D3C"/>
+                  <a:srgbClr val="17283B"/>
                 </a:solidFill>
                 <a:latin typeface="Liberation Sans"/>
               </a:defRPr>
@@ -11273,7 +11273,7 @@
               </a:spcAft>
               <a:defRPr sz="1700" b="0">
                 <a:solidFill>
-                  <a:srgbClr val="647282"/>
+                  <a:srgbClr val="414F60"/>
                 </a:solidFill>
                 <a:latin typeface="Liberation Sans"/>
               </a:defRPr>
@@ -11336,7 +11336,7 @@
               </a:spcAft>
               <a:defRPr sz="900" b="0">
                 <a:solidFill>
-                  <a:srgbClr val="647282"/>
+                  <a:srgbClr val="414F60"/>
                 </a:solidFill>
                 <a:latin typeface="Liberation Sans"/>
               </a:defRPr>
@@ -11375,7 +11375,7 @@
               </a:spcAft>
               <a:defRPr sz="1100" b="0">
                 <a:solidFill>
-                  <a:srgbClr val="647282"/>
+                  <a:srgbClr val="414F60"/>
                 </a:solidFill>
                 <a:latin typeface="Liberation Sans"/>
               </a:defRPr>
@@ -11480,7 +11480,7 @@
               </a:spcAft>
               <a:defRPr sz="1100" b="1">
                 <a:solidFill>
-                  <a:srgbClr val="356696"/>
+                  <a:srgbClr val="164F89"/>
                 </a:solidFill>
                 <a:latin typeface="Liberation Sans"/>
               </a:defRPr>
@@ -11519,7 +11519,7 @@
               </a:spcAft>
               <a:defRPr sz="3100" b="1">
                 <a:solidFill>
-                  <a:srgbClr val="202D3C"/>
+                  <a:srgbClr val="17283B"/>
                 </a:solidFill>
                 <a:latin typeface="Liberation Sans"/>
               </a:defRPr>
@@ -11558,7 +11558,7 @@
               </a:spcAft>
               <a:defRPr sz="1700" b="0">
                 <a:solidFill>
-                  <a:srgbClr val="647282"/>
+                  <a:srgbClr val="414F60"/>
                 </a:solidFill>
                 <a:latin typeface="Liberation Sans"/>
               </a:defRPr>
@@ -11621,7 +11621,7 @@
               </a:spcAft>
               <a:defRPr sz="900" b="0">
                 <a:solidFill>
-                  <a:srgbClr val="647282"/>
+                  <a:srgbClr val="414F60"/>
                 </a:solidFill>
                 <a:latin typeface="Liberation Sans"/>
               </a:defRPr>
@@ -11660,7 +11660,7 @@
               </a:spcAft>
               <a:defRPr sz="1100" b="0">
                 <a:solidFill>
-                  <a:srgbClr val="647282"/>
+                  <a:srgbClr val="414F60"/>
                 </a:solidFill>
                 <a:latin typeface="Liberation Sans"/>
               </a:defRPr>
@@ -11765,7 +11765,7 @@
               </a:spcAft>
               <a:defRPr sz="1100" b="1">
                 <a:solidFill>
-                  <a:srgbClr val="356696"/>
+                  <a:srgbClr val="164F89"/>
                 </a:solidFill>
                 <a:latin typeface="Liberation Sans"/>
               </a:defRPr>
@@ -11804,7 +11804,7 @@
               </a:spcAft>
               <a:defRPr sz="3100" b="1">
                 <a:solidFill>
-                  <a:srgbClr val="202D3C"/>
+                  <a:srgbClr val="17283B"/>
                 </a:solidFill>
                 <a:latin typeface="Liberation Sans"/>
               </a:defRPr>
@@ -11843,7 +11843,7 @@
               </a:spcAft>
               <a:defRPr sz="1700" b="0">
                 <a:solidFill>
-                  <a:srgbClr val="647282"/>
+                  <a:srgbClr val="414F60"/>
                 </a:solidFill>
                 <a:latin typeface="Liberation Sans"/>
               </a:defRPr>
@@ -11906,7 +11906,7 @@
               </a:spcAft>
               <a:defRPr sz="900" b="0">
                 <a:solidFill>
-                  <a:srgbClr val="647282"/>
+                  <a:srgbClr val="414F60"/>
                 </a:solidFill>
                 <a:latin typeface="Liberation Sans"/>
               </a:defRPr>
@@ -11945,7 +11945,7 @@
               </a:spcAft>
               <a:defRPr sz="1100" b="0">
                 <a:solidFill>
-                  <a:srgbClr val="647282"/>
+                  <a:srgbClr val="414F60"/>
                 </a:solidFill>
                 <a:latin typeface="Liberation Sans"/>
               </a:defRPr>
@@ -12050,7 +12050,7 @@
               </a:spcAft>
               <a:defRPr sz="1100" b="1">
                 <a:solidFill>
-                  <a:srgbClr val="356696"/>
+                  <a:srgbClr val="164F89"/>
                 </a:solidFill>
                 <a:latin typeface="Liberation Sans"/>
               </a:defRPr>
@@ -12089,7 +12089,7 @@
               </a:spcAft>
               <a:defRPr sz="3800" b="1">
                 <a:solidFill>
-                  <a:srgbClr val="356696"/>
+                  <a:srgbClr val="164F89"/>
                 </a:solidFill>
                 <a:latin typeface="Liberation Sans"/>
               </a:defRPr>
@@ -12128,7 +12128,7 @@
               </a:spcAft>
               <a:defRPr sz="4100" b="1">
                 <a:solidFill>
-                  <a:srgbClr val="202D3C"/>
+                  <a:srgbClr val="17283B"/>
                 </a:solidFill>
                 <a:latin typeface="Liberation Sans"/>
               </a:defRPr>
@@ -12144,7 +12144,7 @@
               </a:spcAft>
               <a:defRPr sz="4100" b="1">
                 <a:solidFill>
-                  <a:srgbClr val="202D3C"/>
+                  <a:srgbClr val="17283B"/>
                 </a:solidFill>
                 <a:latin typeface="Liberation Sans"/>
               </a:defRPr>
@@ -12183,7 +12183,7 @@
               </a:spcAft>
               <a:defRPr sz="2400" b="0">
                 <a:solidFill>
-                  <a:srgbClr val="356696"/>
+                  <a:srgbClr val="164F89"/>
                 </a:solidFill>
                 <a:latin typeface="Liberation Sans"/>
               </a:defRPr>
@@ -12222,7 +12222,7 @@
               </a:spcAft>
               <a:defRPr sz="2100" b="0">
                 <a:solidFill>
-                  <a:srgbClr val="647282"/>
+                  <a:srgbClr val="414F60"/>
                 </a:solidFill>
                 <a:latin typeface="Liberation Sans"/>
               </a:defRPr>
@@ -12261,7 +12261,7 @@
               </a:spcAft>
               <a:defRPr sz="1500" b="0">
                 <a:solidFill>
-                  <a:srgbClr val="647282"/>
+                  <a:srgbClr val="414F60"/>
                 </a:solidFill>
                 <a:latin typeface="Liberation Sans"/>
               </a:defRPr>
@@ -12300,7 +12300,7 @@
               </a:spcAft>
               <a:defRPr sz="1500" b="1">
                 <a:solidFill>
-                  <a:srgbClr val="356696"/>
+                  <a:srgbClr val="164F89"/>
                 </a:solidFill>
                 <a:latin typeface="Liberation Sans"/>
               </a:defRPr>
@@ -12339,7 +12339,7 @@
               </a:spcAft>
               <a:defRPr sz="1500" b="0">
                 <a:solidFill>
-                  <a:srgbClr val="647282"/>
+                  <a:srgbClr val="414F60"/>
                 </a:solidFill>
                 <a:latin typeface="Liberation Sans"/>
               </a:defRPr>
@@ -12378,7 +12378,7 @@
               </a:spcAft>
               <a:defRPr sz="1500" b="0">
                 <a:solidFill>
-                  <a:srgbClr val="647282"/>
+                  <a:srgbClr val="414F60"/>
                 </a:solidFill>
                 <a:latin typeface="Liberation Sans"/>
               </a:defRPr>
@@ -12417,7 +12417,7 @@
               </a:spcAft>
               <a:defRPr sz="900" b="0">
                 <a:solidFill>
-                  <a:srgbClr val="647282"/>
+                  <a:srgbClr val="414F60"/>
                 </a:solidFill>
                 <a:latin typeface="Liberation Sans"/>
               </a:defRPr>
@@ -12456,7 +12456,7 @@
               </a:spcAft>
               <a:defRPr sz="1100" b="0">
                 <a:solidFill>
-                  <a:srgbClr val="647282"/>
+                  <a:srgbClr val="414F60"/>
                 </a:solidFill>
                 <a:latin typeface="Liberation Sans"/>
               </a:defRPr>
@@ -12561,7 +12561,7 @@
               </a:spcAft>
               <a:defRPr sz="1100" b="1">
                 <a:solidFill>
-                  <a:srgbClr val="356696"/>
+                  <a:srgbClr val="164F89"/>
                 </a:solidFill>
                 <a:latin typeface="Liberation Sans"/>
               </a:defRPr>
@@ -12600,7 +12600,7 @@
               </a:spcAft>
               <a:defRPr sz="3100" b="1">
                 <a:solidFill>
-                  <a:srgbClr val="202D3C"/>
+                  <a:srgbClr val="17283B"/>
                 </a:solidFill>
                 <a:latin typeface="Liberation Sans"/>
               </a:defRPr>
@@ -12639,7 +12639,7 @@
               </a:spcAft>
               <a:defRPr sz="1700" b="0">
                 <a:solidFill>
-                  <a:srgbClr val="647282"/>
+                  <a:srgbClr val="414F60"/>
                 </a:solidFill>
                 <a:latin typeface="Liberation Sans"/>
               </a:defRPr>
@@ -12702,7 +12702,7 @@
               </a:spcAft>
               <a:defRPr sz="900" b="0">
                 <a:solidFill>
-                  <a:srgbClr val="647282"/>
+                  <a:srgbClr val="414F60"/>
                 </a:solidFill>
                 <a:latin typeface="Liberation Sans"/>
               </a:defRPr>
@@ -12741,7 +12741,7 @@
               </a:spcAft>
               <a:defRPr sz="1100" b="0">
                 <a:solidFill>
-                  <a:srgbClr val="647282"/>
+                  <a:srgbClr val="414F60"/>
                 </a:solidFill>
                 <a:latin typeface="Liberation Sans"/>
               </a:defRPr>
@@ -12846,7 +12846,7 @@
               </a:spcAft>
               <a:defRPr sz="1100" b="1">
                 <a:solidFill>
-                  <a:srgbClr val="356696"/>
+                  <a:srgbClr val="164F89"/>
                 </a:solidFill>
                 <a:latin typeface="Liberation Sans"/>
               </a:defRPr>
@@ -12885,7 +12885,7 @@
               </a:spcAft>
               <a:defRPr sz="2850" b="1">
                 <a:solidFill>
-                  <a:srgbClr val="202D3C"/>
+                  <a:srgbClr val="17283B"/>
                 </a:solidFill>
                 <a:latin typeface="Liberation Sans"/>
               </a:defRPr>
@@ -12924,7 +12924,7 @@
               </a:spcAft>
               <a:defRPr sz="1700" b="0">
                 <a:solidFill>
-                  <a:srgbClr val="647282"/>
+                  <a:srgbClr val="414F60"/>
                 </a:solidFill>
                 <a:latin typeface="Liberation Sans"/>
               </a:defRPr>
@@ -12987,7 +12987,7 @@
               </a:spcAft>
               <a:defRPr sz="900" b="0">
                 <a:solidFill>
-                  <a:srgbClr val="647282"/>
+                  <a:srgbClr val="414F60"/>
                 </a:solidFill>
                 <a:latin typeface="Liberation Sans"/>
               </a:defRPr>
@@ -13026,7 +13026,7 @@
               </a:spcAft>
               <a:defRPr sz="1100" b="0">
                 <a:solidFill>
-                  <a:srgbClr val="647282"/>
+                  <a:srgbClr val="414F60"/>
                 </a:solidFill>
                 <a:latin typeface="Liberation Sans"/>
               </a:defRPr>

</xml_diff>

<commit_message>
docs: align NA diagrams with topology visuals and expand ecosystem roadmap
</commit_message>
<xml_diff>
--- a/docs/ppt/Volcano_KubeCon_NA_2026.pptx
+++ b/docs/ppt/Volcano_KubeCon_NA_2026.pptx
@@ -862,7 +862,7 @@
           <a:lstStyle/>
           <a:p>
             <a:r>
-              <a:t>1:15。依次区分已有接入和仍在扩展的能力。Grove 的 SubGroup backend 已合入，不表示支持所有 topology 约束。Kubeflow/LWS 已有接入，下一步深入分组与拓扑。</a:t>
+              <a:t>1:15。左侧讲 Kthena、KubeRay、Grove 的已交付能力及拓扑差距。右侧讲社区后续工作：RBG 正在推进，Kubeflow 计划深化，LWS 推进 multi-group 调度支持。RBG 已有 gang/SubGroup 映射文档，Kubeflow 与 LWS 已有基础接入，不从零开始。后续方向来自 maintainer 计划，不表示已交付。</a:t>
             </a:r>
           </a:p>
           <a:p/>
@@ -906,10 +906,35 @@
               <a:t>https://github.com/kubernetes-sigs/lws/pull/498</a:t>
             </a:r>
           </a:p>
+          <a:p>
+            <a:r>
+              <a:t>https://github.com/sgl-project/rbg/blob/main/doc/features/gang-scheduling.md</a:t>
+            </a:r>
+          </a:p>
+          <a:p>
+            <a:r>
+              <a:t>https://github.com/kubernetes-sigs/lws/blob/main/README.md</a:t>
+            </a:r>
+          </a:p>
           <a:p/>
           <a:p>
             <a:r>
-              <a:t>本页新版素材与说明：Kthena docs; KubeRay #5249 / #5369; Grove #516; Kubeflow Trainer Volcano plugin; LWS #498.</a:t>
+              <a:t>本页新版素材与说明：Kthena docs; KubeRay #5249 / #5369; Grove #516; RBG gang-scheduling docs; Kubeflow Trainer Volcano plugin; LWS README / DisaggregatedSet. Roadmap intent supplied by maintainers.</a:t>
+            </a:r>
+          </a:p>
+          <a:p>
+            <a:r>
+              <a:t>https://github.com/sgl-project/rbg/blob/main/doc/features/gang-scheduling.md</a:t>
+            </a:r>
+          </a:p>
+          <a:p>
+            <a:r>
+              <a:t>https://github.com/kubernetes-sigs/lws/blob/main/README.md</a:t>
+            </a:r>
+          </a:p>
+          <a:p>
+            <a:r>
+              <a:t>右侧为 maintainer 提供的推进方向；RBG 公开文档已有 RoleInstance→SubGroup 基础。LWS 已有副本组，下一步是跨角色 multi-group 调度集成。</a:t>
             </a:r>
           </a:p>
           <a:p>
@@ -7094,7 +7119,7 @@
               </a:defRPr>
             </a:pPr>
             <a:r>
-              <a:t>Integration depth differs: group support and topology support are separate steps.</a:t>
+              <a:t>Existing integrations and the next steps in role, replica, and topology support.</a:t>
             </a:r>
           </a:p>
         </p:txBody>

</xml_diff>

<commit_message>
docs: align diagram ports and rework six NA presentation pages
</commit_message>
<xml_diff>
--- a/docs/ppt/Volcano_KubeCon_NA_2026.pptx
+++ b/docs/ppt/Volcano_KubeCon_NA_2026.pptx
@@ -1771,7 +1771,7 @@
           <a:lstStyle/>
           <a:p>
             <a:r>
-              <a:t>1:10。回扣四部分：路径协同、分组与拓扑、控制器映射、持续验证。邀请社区贡献具体 workload 与复现方式。</a:t>
+              <a:t>1:10。按后续工作收尾：SubGroup 关系；RBG、Kubeflow 与 LWS multi-group 集成；扩展规模、分组与拓扑约束场景的重复测试。每项都明确需要验证的行为，不承诺未经验证的性能提升。</a:t>
             </a:r>
           </a:p>
           <a:p/>
@@ -9915,7 +9915,7 @@
               </a:defRPr>
             </a:pPr>
             <a:r>
-              <a:t>From Measurements to Reliable Comparisons</a:t>
+              <a:t>Benchmark Metrics: Latency and Throughput</a:t>
             </a:r>
           </a:p>
         </p:txBody>
@@ -9954,7 +9954,7 @@
               </a:defRPr>
             </a:pPr>
             <a:r>
-              <a:t>Keep scheduling latency distinct from application readiness.</a:t>
+              <a:t>Separate scheduling delay, runtime readiness, and successful binding throughput.</a:t>
             </a:r>
           </a:p>
         </p:txBody>
@@ -10200,7 +10200,7 @@
               </a:defRPr>
             </a:pPr>
             <a:r>
-              <a:t>Framework, Workloads, Ecosystem, Evidence</a:t>
+              <a:t>What We Will Work On Next</a:t>
             </a:r>
           </a:p>
         </p:txBody>
@@ -10239,7 +10239,7 @@
               </a:defRPr>
             </a:pPr>
             <a:r>
-              <a:t>Four connected pieces of the scheduling story.</a:t>
+              <a:t>Next steps in group placement, controller integration, and benchmarking.</a:t>
             </a:r>
           </a:p>
         </p:txBody>

</xml_diff>

<commit_message>
docs: revise NA talk around group placement and benchmark scenarios
</commit_message>
<xml_diff>
--- a/docs/ppt/Volcano_KubeCon_NA_2026.pptx
+++ b/docs/ppt/Volcano_KubeCon_NA_2026.pptx
@@ -27,6 +27,7 @@
     <p:sldId id="275" r:id="rId27"/>
     <p:sldId id="276" r:id="rId28"/>
     <p:sldId id="277" r:id="rId29"/>
+    <p:sldId id="278" r:id="rId30"/>
   </p:sldIdLst>
   <p:sldSz cx="12191999" cy="6858000" type="screen4x3"/>
   <p:notesSz cx="6858000" cy="9144000"/>
@@ -690,7 +691,7 @@
           <a:lstStyle/>
           <a:p>
             <a:r>
-              <a:t>1:40。先让每个实例聚拢，再用 PodGroup anti-affinity 将两个实例分开。required 和 preferred 的差别是没有理想域时是否允许回退。</a:t>
+              <a:t>1:40。复用第 10 页网络层级及交换机符号，两个 Supernode 共用上层 core fabric。两个完整服务实例各在一个域，避免一次域故障同时影响两份实例。P/D 是简化角色标记，不代表唯一模型结构。Kthena ServingGroup→PodGroup 可作为场景，但 topology affinity 接入截至 2026-10-29 仍是开放 proposal #1478 / issue #645，不能说 Kthena 已交付 anti-affinity。HA 的服务恢复还需 routing/health checks，scheduler 不提供应用故障切换。</a:t>
             </a:r>
           </a:p>
           <a:p/>
@@ -713,6 +714,16 @@
           <a:p>
             <a:r>
               <a:t>本页新版素材与说明：docs/user-guide/how_to_use_podgroup_anti_affinity.md; group-topology-affinity plugin, v1.16.</a:t>
+            </a:r>
+          </a:p>
+          <a:p>
+            <a:r>
+              <a:t>https://github.com/volcano-sh/kthena/pull/1478</a:t>
+            </a:r>
+          </a:p>
+          <a:p>
+            <a:r>
+              <a:t>https://github.com/volcano-sh/kthena/issues/645</a:t>
             </a:r>
           </a:p>
           <a:p>
@@ -792,7 +803,44 @@
           <a:lstStyle/>
           <a:p>
             <a:r>
-              <a:t>0:10。转场：这些分组和拓扑语义，最终要由用户真正使用的 controller 传进来。</a:t>
+              <a:t>1:20。放在第二章，以相同 fabric 演进关系语义。同一个 PodGroup 的 Prefill 与两个 Decode SubGroup 都位于 Supernode A，满足上层亲和；两个 Decode 副本分别位于 Leaf 0 与 Leaf 1，满足更细层级的反亲和。每个 SubGroup 都是完整两 Pod 组。Supernode B 和其他空闲 rack 表明这些约束是有选择的放置，而非资源只剩此处。关系 API 为 proposed，不提供伪造的可执行 YAML。</a:t>
+            </a:r>
+          </a:p>
+          <a:p/>
+          <a:p>
+            <a:r>
+              <a:t>技术来源：</a:t>
+            </a:r>
+          </a:p>
+          <a:p>
+            <a:r>
+              <a:t>https://github.com/volcano-sh/volcano/releases/tag/v1.16.0</a:t>
+            </a:r>
+          </a:p>
+          <a:p>
+            <a:r>
+              <a:t>https://github.com/volcano-sh/volcano/issues/6166</a:t>
+            </a:r>
+          </a:p>
+          <a:p>
+            <a:r>
+              <a:t>https://github.com/volcano-sh/volcano/blob/v1.16.0/docs/design/group-topology-affinity.md</a:t>
+            </a:r>
+          </a:p>
+          <a:p/>
+          <a:p>
+            <a:r>
+              <a:t>本页新版素材与说明：docs/design/group-topology-affinity.md (proposed SubGroup relationships); roadmap #6166.</a:t>
+            </a:r>
+          </a:p>
+          <a:p>
+            <a:r>
+              <a:t>本页为未来方向，不能当作已交付 API。示意同一 PodGroup 内将协作组放近、将副本分开；具体 selector 与亲和关系设计仍需社区讨论。</a:t>
+            </a:r>
+          </a:p>
+          <a:p>
+            <a:r>
+              <a:t>Visual: na2026/svg/12-subgroup-next.svg。PNG 固定几何；复用的旧图原本为位图，新增 YAML 和注释为 SVG 文本。</a:t>
             </a:r>
           </a:p>
         </p:txBody>
@@ -862,84 +910,7 @@
           <a:lstStyle/>
           <a:p>
             <a:r>
-              <a:t>1:15。左侧讲 Kthena、KubeRay、Grove 的已交付能力及拓扑差距。右侧讲社区后续工作：RBG 正在推进，Kubeflow 计划深化，LWS 推进 multi-group 调度支持。RBG 已有 gang/SubGroup 映射文档，Kubeflow 与 LWS 已有基础接入，不从零开始。后续方向来自 maintainer 计划，不表示已交付。</a:t>
-            </a:r>
-          </a:p>
-          <a:p/>
-          <a:p>
-            <a:r>
-              <a:t>技术来源：</a:t>
-            </a:r>
-          </a:p>
-          <a:p>
-            <a:r>
-              <a:t>https://github.com/volcano-sh/kthena/blob/main/docs/kthena/versioned_docs/version-v1.0.0/user-guide/gang-scheduling.md</a:t>
-            </a:r>
-          </a:p>
-          <a:p>
-            <a:r>
-              <a:t>https://github.com/volcano-sh/kthena/blob/main/docs/kthena/versioned_docs/version-v1.0.0/user-guide/network-topology.md</a:t>
-            </a:r>
-          </a:p>
-          <a:p>
-            <a:r>
-              <a:t>https://github.com/kuberay-project/kuberay/pull/5249</a:t>
-            </a:r>
-          </a:p>
-          <a:p>
-            <a:r>
-              <a:t>https://github.com/kuberay-project/kuberay/pull/5369</a:t>
-            </a:r>
-          </a:p>
-          <a:p>
-            <a:r>
-              <a:t>https://github.com/ai-dynamo/grove/pull/516</a:t>
-            </a:r>
-          </a:p>
-          <a:p>
-            <a:r>
-              <a:t>https://trainer.kubeflow.org/en/latest/operator-guides/job-scheduling/volcano.html</a:t>
-            </a:r>
-          </a:p>
-          <a:p>
-            <a:r>
-              <a:t>https://github.com/kubernetes-sigs/lws/pull/498</a:t>
-            </a:r>
-          </a:p>
-          <a:p>
-            <a:r>
-              <a:t>https://github.com/sgl-project/rbg/blob/main/doc/features/gang-scheduling.md</a:t>
-            </a:r>
-          </a:p>
-          <a:p>
-            <a:r>
-              <a:t>https://github.com/kubernetes-sigs/lws/blob/main/README.md</a:t>
-            </a:r>
-          </a:p>
-          <a:p/>
-          <a:p>
-            <a:r>
-              <a:t>本页新版素材与说明：Kthena docs; KubeRay #5249 / #5369; Grove #516; RBG gang-scheduling docs; Kubeflow Trainer Volcano plugin; LWS README / DisaggregatedSet. Roadmap intent supplied by maintainers.</a:t>
-            </a:r>
-          </a:p>
-          <a:p>
-            <a:r>
-              <a:t>https://github.com/sgl-project/rbg/blob/main/doc/features/gang-scheduling.md</a:t>
-            </a:r>
-          </a:p>
-          <a:p>
-            <a:r>
-              <a:t>https://github.com/kubernetes-sigs/lws/blob/main/README.md</a:t>
-            </a:r>
-          </a:p>
-          <a:p>
-            <a:r>
-              <a:t>右侧为 maintainer 提供的推进方向；RBG 公开文档已有 RoleInstance→SubGroup 基础。LWS 已有副本组，下一步是跨角色 multi-group 调度集成。</a:t>
-            </a:r>
-          </a:p>
-          <a:p>
-            <a:r>
-              <a:t>Visual: na2026/svg/13-ecosystem.svg。PNG 固定几何；复用的旧图原本为位图，新增 YAML 和注释为 SVG 文本。</a:t>
+              <a:t>0:10。转场：这些分组和拓扑语义，最终要由用户真正使用的 controller 传进来。</a:t>
             </a:r>
           </a:p>
         </p:txBody>
@@ -1203,44 +1174,23 @@
           <a:lstStyle/>
           <a:p>
             <a:r>
-              <a:t>1:10。说明后续在同一个 PodGroup 内表达 SubGroup affinity/anti-affinity 的方向。图是意图示例，不提供假装已可执行的未来 YAML。</a:t>
+              <a:t>0:50。根据 Grove main 的实际 Volcano backend：一个 PodGang 生成一个 Volcano PodGroup；PodGang.spec.podGroups 中每一项生成 SubGroup policy，name 和 PodClique label 选中组，subGroupSize=max(minReplicas,1)，minSubGroups=1。图示两个组分别 2 和 4 Pods，总 minMember=6。当前 main 明确拒绝 PodCliqueSet / PodClique / PodCliqueScalingGroup 上的 topologyConstraint。区分已合入的 adapter 与发布版本支持；不要只依据 #516 初始 PR 描述判断后续 main。</a:t>
+            </a:r>
+          </a:p>
+          <a:p>
+            <a:r>
+              <a:t>https://github.com/NVIDIA/grove/blob/main/operator/internal/scheduler/volcano/backend.go</a:t>
             </a:r>
           </a:p>
           <a:p/>
           <a:p>
             <a:r>
-              <a:t>技术来源：</a:t>
-            </a:r>
-          </a:p>
-          <a:p>
-            <a:r>
-              <a:t>https://github.com/volcano-sh/volcano/releases/tag/v1.16.0</a:t>
-            </a:r>
-          </a:p>
-          <a:p>
-            <a:r>
-              <a:t>https://github.com/volcano-sh/volcano/issues/6166</a:t>
-            </a:r>
-          </a:p>
-          <a:p>
-            <a:r>
-              <a:t>https://github.com/volcano-sh/volcano/blob/v1.16.0/docs/design/group-topology-affinity.md</a:t>
-            </a:r>
-          </a:p>
-          <a:p/>
-          <a:p>
-            <a:r>
-              <a:t>本页新版素材与说明：docs/design/group-topology-affinity.md (proposed SubGroup relationships); roadmap #6166.</a:t>
-            </a:r>
-          </a:p>
-          <a:p>
-            <a:r>
-              <a:t>本页为未来方向，不能当作已交付 API。示意同一 PodGroup 内将协作组放近、将副本分开；具体 selector 与亲和关系设计仍需社区讨论。</a:t>
-            </a:r>
-          </a:p>
-          <a:p>
-            <a:r>
-              <a:t>Visual: na2026/svg/16-subgroup-next.svg。PNG 固定几何；复用的旧图原本为位图，新增 YAML 和注释为 SVG 文本。</a:t>
+              <a:t>本页新版素材与说明：https://github.com/NVIDIA/grove/blob/1d8f83b38a3f54d9827bb579a68c0315ed54ce91/operator/internal/scheduler/volcano/backend.go (reviewed 2026-10-29); #516 merged. topologyConstraint is currently rejected.</a:t>
+            </a:r>
+          </a:p>
+          <a:p>
+            <a:r>
+              <a:t>Visual: na2026/svg/16-grove-mapping.svg。PNG 固定几何；复用的旧图原本为位图，新增 YAML 和注释为 SVG 文本。</a:t>
             </a:r>
           </a:p>
         </p:txBody>
@@ -1310,7 +1260,84 @@
           <a:lstStyle/>
           <a:p>
             <a:r>
-              <a:t>0:10。转场：接入的控制器和约束越多，就越需要可重复的 benchmark。</a:t>
+              <a:t>0:50。具体 Kthena、KubeRay、Grove 案例之后再讲后续社区方向。RBG 推进中，已有 RoleInstance→SubGroup 基础；Kubeflow 计划在现有 Volcano 插件上深化分组及拓扑；LWS 计划 multi-role/multi-group 支持。状态来自 maintainer 的推进计划，不能写作全部已交付。</a:t>
+            </a:r>
+          </a:p>
+          <a:p/>
+          <a:p>
+            <a:r>
+              <a:t>技术来源：</a:t>
+            </a:r>
+          </a:p>
+          <a:p>
+            <a:r>
+              <a:t>https://github.com/volcano-sh/kthena/blob/main/docs/kthena/versioned_docs/version-v1.0.0/user-guide/gang-scheduling.md</a:t>
+            </a:r>
+          </a:p>
+          <a:p>
+            <a:r>
+              <a:t>https://github.com/volcano-sh/kthena/blob/main/docs/kthena/versioned_docs/version-v1.0.0/user-guide/network-topology.md</a:t>
+            </a:r>
+          </a:p>
+          <a:p>
+            <a:r>
+              <a:t>https://github.com/kuberay-project/kuberay/pull/5249</a:t>
+            </a:r>
+          </a:p>
+          <a:p>
+            <a:r>
+              <a:t>https://github.com/kuberay-project/kuberay/pull/5369</a:t>
+            </a:r>
+          </a:p>
+          <a:p>
+            <a:r>
+              <a:t>https://github.com/ai-dynamo/grove/pull/516</a:t>
+            </a:r>
+          </a:p>
+          <a:p>
+            <a:r>
+              <a:t>https://trainer.kubeflow.org/en/latest/operator-guides/job-scheduling/volcano.html</a:t>
+            </a:r>
+          </a:p>
+          <a:p>
+            <a:r>
+              <a:t>https://github.com/kubernetes-sigs/lws/pull/498</a:t>
+            </a:r>
+          </a:p>
+          <a:p>
+            <a:r>
+              <a:t>https://github.com/sgl-project/rbg/blob/main/doc/features/gang-scheduling.md</a:t>
+            </a:r>
+          </a:p>
+          <a:p>
+            <a:r>
+              <a:t>https://github.com/kubernetes-sigs/lws/blob/main/README.md</a:t>
+            </a:r>
+          </a:p>
+          <a:p/>
+          <a:p>
+            <a:r>
+              <a:t>本页新版素材与说明：Kthena docs; KubeRay #5249 / #5369; Grove #516; RBG gang-scheduling docs; Kubeflow Trainer Volcano plugin; LWS README / DisaggregatedSet. Roadmap intent supplied by maintainers.</a:t>
+            </a:r>
+          </a:p>
+          <a:p>
+            <a:r>
+              <a:t>https://github.com/sgl-project/rbg/blob/main/doc/features/gang-scheduling.md</a:t>
+            </a:r>
+          </a:p>
+          <a:p>
+            <a:r>
+              <a:t>https://github.com/kubernetes-sigs/lws/blob/main/README.md</a:t>
+            </a:r>
+          </a:p>
+          <a:p>
+            <a:r>
+              <a:t>右侧为 maintainer 提供的推进方向；RBG 公开文档已有 RoleInstance→SubGroup 基础。LWS 已有副本组，下一步是跨角色 multi-group 调度集成。</a:t>
+            </a:r>
+          </a:p>
+          <a:p>
+            <a:r>
+              <a:t>Visual: na2026/svg/17-ecosystem.svg。PNG 固定几何；复用的旧图原本为位图，新增 YAML 和注释为 SVG 文本。</a:t>
             </a:r>
           </a:p>
         </p:txBody>
@@ -1380,34 +1407,7 @@
           <a:lstStyle/>
           <a:p>
             <a:r>
-              <a:t>1:30。沿数据路径解释 benchmark：场景输入→API/调度器→audit-exporter 与 Prometheus→报告。KWOK 只验证调度行为，不代表真实 GPU 执行吞吐。</a:t>
-            </a:r>
-          </a:p>
-          <a:p/>
-          <a:p>
-            <a:r>
-              <a:t>技术来源：</a:t>
-            </a:r>
-          </a:p>
-          <a:p>
-            <a:r>
-              <a:t>https://github.com/volcano-sh/volcano/blob/a3d50b503/benchmark/README.md</a:t>
-            </a:r>
-          </a:p>
-          <a:p>
-            <a:r>
-              <a:t>https://github.com/volcano-sh/volcano/blob/a3d50b503/benchmark/scripts/README.md</a:t>
-            </a:r>
-          </a:p>
-          <a:p/>
-          <a:p>
-            <a:r>
-              <a:t>本页新版素材与说明：benchmark/README.md; benchmark/scripts; benchmark/config; benchmark/testcases.</a:t>
-            </a:r>
-          </a:p>
-          <a:p>
-            <a:r>
-              <a:t>Visual: na2026/svg/18-benchmark-architecture.svg。PNG 固定几何；复用的旧图原本为位图，新增 YAML 和注释为 SVG 文本。</a:t>
+              <a:t>0:10。转场：接入的控制器和约束越多，就越需要可重复的 benchmark。</a:t>
             </a:r>
           </a:p>
         </p:txBody>
@@ -1477,7 +1477,7 @@
           <a:lstStyle/>
           <a:p>
             <a:r>
-              <a:t>1:20。已有框架、场景和观察能力是本章可以确定展示的进展。继续验证规模、约束和优化，不为了演讲单独制造漂亮结果。命令仅展示框架用法，本次没有运行集群测试。</a:t>
+              <a:t>1:30。沿数据路径解释 benchmark：场景输入→API/调度器→audit-exporter 与 Prometheus→报告。KWOK 只验证调度行为，不代表真实 GPU 执行吞吐。</a:t>
             </a:r>
           </a:p>
           <a:p/>
@@ -1488,28 +1488,23 @@
           </a:p>
           <a:p>
             <a:r>
-              <a:t>https://github.com/volcano-sh/volcano/blob/a3d50b503/benchmark/scripts/collect-report.sh</a:t>
-            </a:r>
-          </a:p>
-          <a:p>
-            <a:r>
-              <a:t>https://github.com/volcano-sh/volcano/blob/a3d50b503/benchmark/manifests/monitoring/grafana-dashboard.json</a:t>
-            </a:r>
-          </a:p>
-          <a:p>
-            <a:r>
-              <a:t>https://github.com/volcano-sh/volcano/issues/6166</a:t>
+              <a:t>https://github.com/volcano-sh/volcano/blob/a3d50b503/benchmark/README.md</a:t>
+            </a:r>
+          </a:p>
+          <a:p>
+            <a:r>
+              <a:t>https://github.com/volcano-sh/volcano/blob/a3d50b503/benchmark/scripts/README.md</a:t>
             </a:r>
           </a:p>
           <a:p/>
           <a:p>
             <a:r>
-              <a:t>本页新版素材与说明：benchmark/README.md; benchmark/Makefile; benchmark/scripts/collect-report.sh.</a:t>
-            </a:r>
-          </a:p>
-          <a:p>
-            <a:r>
-              <a:t>Visual: na2026/svg/19-benchmark-progress.svg。PNG 固定几何；复用的旧图原本为位图，新增 YAML 和注释为 SVG 文本。</a:t>
+              <a:t>本页新版素材与说明：benchmark/README.md; benchmark/scripts; benchmark/config; benchmark/testcases.</a:t>
+            </a:r>
+          </a:p>
+          <a:p>
+            <a:r>
+              <a:t>Visual: na2026/svg/19-benchmark-architecture.svg。PNG 固定几何；复用的旧图原本为位图，新增 YAML 和注释为 SVG 文本。</a:t>
             </a:r>
           </a:p>
         </p:txBody>
@@ -1579,7 +1574,17 @@
           <a:lstStyle/>
           <a:p>
             <a:r>
-              <a:t>0:40。简介暂依据公开资料；Ricardo 当前公司和正式职务不确定，未填公司。收到讲者偏好后更新文字与头像。照片来自 Linux Foundation 公开讲者页。</a:t>
+              <a:t>0:40。Ricardo：NA 2026 官方会议资料列为 Nunchux AI 的 AI Infrastructure Lead；CNCF TOC 页面列为 TOC Alternate (GB)，不是 Governing Board 成员，不写 Founder 或 CEO。2026-10-29 核查。照片来自 Linux Foundation 公开讲者页。</a:t>
+            </a:r>
+          </a:p>
+          <a:p>
+            <a:r>
+              <a:t>https://events.linuxfoundation.org/kubecon-cloudnativecon-north-america/program/schedule/?id=1289640</a:t>
+            </a:r>
+          </a:p>
+          <a:p>
+            <a:r>
+              <a:t>https://www.cncf.io/people/technical-oversight-committee/</a:t>
             </a:r>
           </a:p>
           <a:p>
@@ -1669,7 +1674,7 @@
           <a:lstStyle/>
           <a:p>
             <a:r>
-              <a:t>1:20。讲清 created→scheduled 的统计口径、吞吐窗口和对照条件。仍待选定一项代表性结果，可以后续原位替换本页。</a:t>
+              <a:t>1:20。已有 harness 为重复场景和指标采集打底。后续在同样集群容量、相同 workload arrivals/grouping/resources 下逐个运行不同 scheduler；每次 reset，不能让调度器同时竞争资源。固定每个实现的版本、配置和指标口径；记录各自合理调参后的配置。Kubernetes scheduler 可作为支持场景的 baseline，其他调度器集合待确定。未支持 gang 或 topology 的调度器不强行比较相同语义，须标注差异。比较 tail latency、binding throughput、完整 gang 数及放置正确性，不展示虚构结果。</a:t>
             </a:r>
           </a:p>
           <a:p/>
@@ -1680,28 +1685,28 @@
           </a:p>
           <a:p>
             <a:r>
-              <a:t>https://github.com/volcano-sh/volcano/blob/a3d50b503/benchmark/README.md</a:t>
-            </a:r>
-          </a:p>
-          <a:p>
-            <a:r>
               <a:t>https://github.com/volcano-sh/volcano/blob/a3d50b503/benchmark/scripts/collect-report.sh</a:t>
             </a:r>
           </a:p>
+          <a:p>
+            <a:r>
+              <a:t>https://github.com/volcano-sh/volcano/blob/a3d50b503/benchmark/manifests/monitoring/grafana-dashboard.json</a:t>
+            </a:r>
+          </a:p>
+          <a:p>
+            <a:r>
+              <a:t>https://github.com/volcano-sh/volcano/issues/6166</a:t>
+            </a:r>
+          </a:p>
           <a:p/>
           <a:p>
             <a:r>
-              <a:t>本页新版素材与说明：benchmark/scripts/collect-report.sh and audit-exporter event definitions. No performance results selected.</a:t>
-            </a:r>
-          </a:p>
-          <a:p>
-            <a:r>
-              <a:t>尚未选定代表性 benchmark 结果，本页只讲测量口径，不呈现虚构性能曲线或提升比例。</a:t>
-            </a:r>
-          </a:p>
-          <a:p>
-            <a:r>
-              <a:t>Visual: na2026/svg/20-benchmark-measurement.svg。PNG 固定几何；复用的旧图原本为位图，新增 YAML 和注释为 SVG 文本。</a:t>
+              <a:t>本页新版素材与说明：benchmark/README.md; benchmark/Makefile; benchmark/scripts/collect-report.sh.</a:t>
+            </a:r>
+          </a:p>
+          <a:p>
+            <a:r>
+              <a:t>Visual: na2026/svg/20-benchmark-progress.svg。PNG 固定几何；复用的旧图原本为位图，新增 YAML 和注释为 SVG 文本。</a:t>
             </a:r>
           </a:p>
         </p:txBody>
@@ -1771,7 +1776,7 @@
           <a:lstStyle/>
           <a:p>
             <a:r>
-              <a:t>1:10。按后续工作收尾：SubGroup 关系；RBG、Kubeflow 与 LWS multi-group 集成；扩展规模、分组与拓扑约束场景的重复测试。每项都明确需要验证的行为，不承诺未经验证的性能提升。</a:t>
+              <a:t>1:20。选择代表性场景，寻找每种 scheduler 的适用边界，不只找有利 Volcano 的配置。第一类改变 arrival rate、预留容量，观察突发的尾延迟和积压恢复；只测试 pool 容量请求的调度，不用 KWOK 宣称完整 agent runtime 延迟。第二类改变 SubGroup 大小和可用资源碎片，观察完整 gangs 和 binding throughput。第三类组合 topology tier limits、可用域、gang/anti-affinity，检查 placement correctness 与完成延迟。KWOK 可以验证调度行为；NCCL/KV 带宽及实际模型吞吐需要真实硬件另测。本页是 ongoing/planned test matrix，没有 benchmark 数字。</a:t>
             </a:r>
           </a:p>
           <a:p/>
@@ -1782,23 +1787,28 @@
           </a:p>
           <a:p>
             <a:r>
-              <a:t>https://github.com/volcano-sh/volcano/issues/6166</a:t>
-            </a:r>
-          </a:p>
-          <a:p>
-            <a:r>
               <a:t>https://github.com/volcano-sh/volcano/blob/a3d50b503/benchmark/README.md</a:t>
             </a:r>
           </a:p>
+          <a:p>
+            <a:r>
+              <a:t>https://github.com/volcano-sh/volcano/blob/a3d50b503/benchmark/scripts/collect-report.sh</a:t>
+            </a:r>
+          </a:p>
           <a:p/>
           <a:p>
             <a:r>
-              <a:t>本页新版素材与说明：</a:t>
-            </a:r>
-          </a:p>
-          <a:p>
-            <a:r>
-              <a:t>Visual: na2026/svg/21-takeaways.svg。PNG 固定几何；复用的旧图原本为位图，新增 YAML 和注释为 SVG 文本。</a:t>
+              <a:t>本页新版素材与说明：benchmark/scripts/collect-report.sh and audit-exporter event definitions. No performance results selected.</a:t>
+            </a:r>
+          </a:p>
+          <a:p>
+            <a:r>
+              <a:t>口径：scheduledAt−createdAt；binding throughput 为成功 bindings / 首尾成功 bind 时间差。对照时保留原始事件、重复次数与环境配置。命令与完整指标定义见 benchmark/README.md。</a:t>
+            </a:r>
+          </a:p>
+          <a:p>
+            <a:r>
+              <a:t>Visual: na2026/svg/21-benchmark-measurement.svg。PNG 固定几何；复用的旧图原本为位图，新增 YAML 和注释为 SVG 文本。</a:t>
             </a:r>
           </a:p>
         </p:txBody>
@@ -1868,6 +1878,103 @@
           <a:lstStyle/>
           <a:p>
             <a:r>
+              <a:t>1:00。收尾强调下一步：SubGroup affinity/anti-affinity 的语义与实现；RBG/Kubeflow/LWS multi-group 的社区工作；多调度器横向对照、代表性场景及 topology-aware gang 测试。</a:t>
+            </a:r>
+          </a:p>
+          <a:p/>
+          <a:p>
+            <a:r>
+              <a:t>技术来源：</a:t>
+            </a:r>
+          </a:p>
+          <a:p>
+            <a:r>
+              <a:t>https://github.com/volcano-sh/volcano/issues/6166</a:t>
+            </a:r>
+          </a:p>
+          <a:p>
+            <a:r>
+              <a:t>https://github.com/volcano-sh/volcano/blob/a3d50b503/benchmark/README.md</a:t>
+            </a:r>
+          </a:p>
+          <a:p/>
+          <a:p>
+            <a:r>
+              <a:t>本页新版素材与说明：</a:t>
+            </a:r>
+          </a:p>
+          <a:p>
+            <a:r>
+              <a:t>Visual: na2026/svg/22-takeaways.svg。PNG 固定几何；复用的旧图原本为位图，新增 YAML 和注释为 SVG 文本。</a:t>
+            </a:r>
+          </a:p>
+        </p:txBody>
+      </p:sp>
+      <p:sp>
+        <p:nvSpPr>
+          <p:cNvPr id="4" name="Slide Number Placeholder 3"/>
+          <p:cNvSpPr>
+            <a:spLocks noGrp="1"/>
+          </p:cNvSpPr>
+          <p:nvPr>
+            <p:ph type="sldNum" idx="5" sz="quarter"/>
+          </p:nvPr>
+        </p:nvSpPr>
+        <p:spPr/>
+      </p:sp>
+    </p:spTree>
+  </p:cSld>
+  <p:clrMapOvr>
+    <a:masterClrMapping/>
+  </p:clrMapOvr>
+</p:notes>
+</file>
+
+<file path=ppt/notesSlides/notesSlide23.xml><?xml version="1.0" encoding="utf-8"?>
+<p:notes xmlns:a="http://schemas.openxmlformats.org/drawingml/2006/main" xmlns:p="http://schemas.openxmlformats.org/presentationml/2006/main" xmlns:r="http://schemas.openxmlformats.org/officeDocument/2006/relationships">
+  <p:cSld>
+    <p:spTree>
+      <p:nvGrpSpPr>
+        <p:cNvPr id="1" name=""/>
+        <p:cNvGrpSpPr/>
+        <p:nvPr/>
+      </p:nvGrpSpPr>
+      <p:grpSpPr>
+        <a:xfrm>
+          <a:off x="0" y="0"/>
+          <a:ext cx="0" cy="0"/>
+          <a:chOff x="0" y="0"/>
+          <a:chExt cx="0" cy="0"/>
+        </a:xfrm>
+      </p:grpSpPr>
+      <p:sp>
+        <p:nvSpPr>
+          <p:cNvPr id="2" name="Slide Image Placeholder 1"/>
+          <p:cNvSpPr>
+            <a:spLocks noGrp="1"/>
+          </p:cNvSpPr>
+          <p:nvPr>
+            <p:ph type="sldImg" idx="2"/>
+          </p:nvPr>
+        </p:nvSpPr>
+        <p:spPr/>
+      </p:sp>
+      <p:sp>
+        <p:nvSpPr>
+          <p:cNvPr id="3" name="Notes Placeholder 2"/>
+          <p:cNvSpPr>
+            <a:spLocks noGrp="1"/>
+          </p:cNvSpPr>
+          <p:nvPr>
+            <p:ph type="body" idx="3" sz="quarter"/>
+          </p:nvPr>
+        </p:nvSpPr>
+        <p:spPr/>
+        <p:txBody>
+          <a:bodyPr/>
+          <a:lstStyle/>
+          <a:p>
+            <a:r>
               <a:t>5:00。问答。优先收集工作负载如何分组、需要哪些拓扑关系，以及可重复的测试场景。</a:t>
             </a:r>
           </a:p>
@@ -1900,7 +2007,7 @@
           </a:p>
           <a:p>
             <a:r>
-              <a:t>Visual: na2026/svg/22-questions.svg。PNG 固定几何；复用的旧图原本为位图，新增 YAML 和注释为 SVG 文本。</a:t>
+              <a:t>Visual: na2026/svg/23-questions.svg。PNG 固定几何；复用的旧图原本为位图，新增 YAML 和注释为 SVG 文本。</a:t>
             </a:r>
           </a:p>
         </p:txBody>
@@ -2040,7 +2147,7 @@
           <a:lstStyle/>
           <a:p>
             <a:r>
-              <a:t>1:00。先讲共同的基础设施需求：训练/RL 更强调协同计算，推理有角色与副本结构，agent 业务带来突发和延迟压力。并非每次 agent 调用都要创建一个 Pod。</a:t>
+              <a:t>1:20。训练图展示两个 PP stage，每个 stage 两个 TP ranks，需要完整子组及通信局部性。推理展示 P/D 分离，不同角色及副本的 gang 与 topology 约束。Agent 路径先命中预热池并复用 ready runtime；池子耗尽时由 runtime/pool controller 请求容量，经快速 Pod 调度补池。请求突发图是需求示意，没有测量值。池管理不是 Volcano 自带能力，也不是每次调用创建 Pod。</a:t>
             </a:r>
           </a:p>
           <a:p/>
@@ -5871,7 +5978,7 @@
               </a:defRPr>
             </a:pPr>
             <a:r>
-              <a:t>01 / 22</a:t>
+              <a:t>01 / 23</a:t>
             </a:r>
           </a:p>
         </p:txBody>
@@ -6156,7 +6263,7 @@
               </a:defRPr>
             </a:pPr>
             <a:r>
-              <a:t>10 / 22</a:t>
+              <a:t>10 / 23</a:t>
             </a:r>
           </a:p>
         </p:txBody>
@@ -6339,7 +6446,7 @@
               </a:defRPr>
             </a:pPr>
             <a:r>
-              <a:t>PodGroup anti-affinity separates service instances across HyperNode domains.</a:t>
+              <a:t>ServingGroup → PodGroup: a Kthena scenario. Anti-affinity integration in Kthena is proposed.</a:t>
             </a:r>
           </a:p>
         </p:txBody>
@@ -6441,7 +6548,7 @@
               </a:defRPr>
             </a:pPr>
             <a:r>
-              <a:t>11 / 22</a:t>
+              <a:t>11 / 23</a:t>
             </a:r>
           </a:p>
         </p:txBody>
@@ -6466,7 +6573,7 @@
       <p:grpSpPr/>
       <p:pic>
         <p:nvPicPr>
-          <p:cNvPr id="2" name="Picture 1" descr="cover-background.png"/>
+          <p:cNvPr id="2" name="Picture 1" descr="background.png"/>
           <p:cNvPicPr>
             <a:picLocks noChangeAspect="1"/>
           </p:cNvPicPr>
@@ -6546,7 +6653,7 @@
               </a:defRPr>
             </a:pPr>
             <a:r>
-              <a:t>ECOSYSTEM</a:t>
+              <a:t>MULTI-LEVEL GANG &amp; NETWORK TOPOLOGY</a:t>
             </a:r>
           </a:p>
         </p:txBody>
@@ -6559,8 +6666,8 @@
         </p:nvSpPr>
         <p:spPr>
           <a:xfrm>
-            <a:off x="594360" y="1298448"/>
-            <a:ext cx="1828800" cy="640080"/>
+            <a:off x="457200" y="804672"/>
+            <a:ext cx="11247120" cy="640080"/>
           </a:xfrm>
           <a:prstGeom prst="rect">
             <a:avLst/>
@@ -6577,15 +6684,15 @@
               <a:spcAft>
                 <a:spcPts val="500"/>
               </a:spcAft>
-              <a:defRPr sz="3800" b="1">
-                <a:solidFill>
-                  <a:srgbClr val="164F89"/>
-                </a:solidFill>
-                <a:latin typeface="Liberation Sans"/>
-              </a:defRPr>
-            </a:pPr>
-            <a:r>
-              <a:t>03</a:t>
+              <a:defRPr sz="3100" b="1">
+                <a:solidFill>
+                  <a:srgbClr val="17283B"/>
+                </a:solidFill>
+                <a:latin typeface="Liberation Sans"/>
+              </a:defRPr>
+            </a:pPr>
+            <a:r>
+              <a:t>Next: Relationships Between SubGroups</a:t>
             </a:r>
           </a:p>
         </p:txBody>
@@ -6598,8 +6705,8 @@
         </p:nvSpPr>
         <p:spPr>
           <a:xfrm>
-            <a:off x="594360" y="2084831"/>
-            <a:ext cx="7863840" cy="1508760"/>
+            <a:off x="475488" y="1435608"/>
+            <a:ext cx="11201400" cy="429768"/>
           </a:xfrm>
           <a:prstGeom prst="rect">
             <a:avLst/>
@@ -6616,256 +6723,46 @@
               <a:spcAft>
                 <a:spcPts val="500"/>
               </a:spcAft>
-              <a:defRPr sz="4100" b="1">
-                <a:solidFill>
-                  <a:srgbClr val="17283B"/>
-                </a:solidFill>
-                <a:latin typeface="Liberation Sans"/>
-              </a:defRPr>
-            </a:pPr>
-            <a:r>
-              <a:t>Ecosystem</a:t>
-            </a:r>
-          </a:p>
-        </p:txBody>
-      </p:sp>
-      <p:sp>
-        <p:nvSpPr>
-          <p:cNvPr id="7" name="TextBox 6"/>
-          <p:cNvSpPr txBox="1"/>
-          <p:nvPr/>
-        </p:nvSpPr>
-        <p:spPr>
-          <a:xfrm>
-            <a:off x="621792" y="4041648"/>
-            <a:ext cx="9966960" cy="548640"/>
-          </a:xfrm>
-          <a:prstGeom prst="rect">
-            <a:avLst/>
-          </a:prstGeom>
-          <a:noFill/>
-        </p:spPr>
-        <p:txBody>
-          <a:bodyPr wrap="square" lIns="0" rIns="0" tIns="0" bIns="0">
-            <a:spAutoFit/>
-          </a:bodyPr>
-          <a:lstStyle/>
-          <a:p>
-            <a:pPr>
-              <a:spcAft>
-                <a:spcPts val="500"/>
-              </a:spcAft>
-              <a:defRPr sz="2400" b="0">
-                <a:solidFill>
-                  <a:srgbClr val="164F89"/>
-                </a:solidFill>
-                <a:latin typeface="Liberation Sans"/>
-              </a:defRPr>
-            </a:pPr>
-            <a:r>
-              <a:t>Workload controllers carry scheduling intent.</a:t>
-            </a:r>
-          </a:p>
-        </p:txBody>
-      </p:sp>
+              <a:defRPr sz="1700" b="0">
+                <a:solidFill>
+                  <a:srgbClr val="414F60"/>
+                </a:solidFill>
+                <a:latin typeface="Liberation Sans"/>
+              </a:defRPr>
+            </a:pPr>
+            <a:r>
+              <a:t>Keep cooperating groups local while separating replicas inside the same PodGroup.</a:t>
+            </a:r>
+          </a:p>
+        </p:txBody>
+      </p:sp>
+      <p:pic>
+        <p:nvPicPr>
+          <p:cNvPr id="7" name="Picture 6" descr="12-subgroup-next.png"/>
+          <p:cNvPicPr>
+            <a:picLocks noChangeAspect="1"/>
+          </p:cNvPicPr>
+          <p:nvPr/>
+        </p:nvPicPr>
+        <p:blipFill>
+          <a:blip r:embed="rId4"/>
+          <a:stretch>
+            <a:fillRect/>
+          </a:stretch>
+        </p:blipFill>
+        <p:spPr>
+          <a:xfrm>
+            <a:off x="457200" y="1938528"/>
+            <a:ext cx="11277599" cy="4267200"/>
+          </a:xfrm>
+          <a:prstGeom prst="rect">
+            <a:avLst/>
+          </a:prstGeom>
+        </p:spPr>
+      </p:pic>
       <p:sp>
         <p:nvSpPr>
           <p:cNvPr id="8" name="TextBox 7"/>
-          <p:cNvSpPr txBox="1"/>
-          <p:nvPr/>
-        </p:nvSpPr>
-        <p:spPr>
-          <a:xfrm>
-            <a:off x="621792" y="4791456"/>
-            <a:ext cx="10607040" cy="594360"/>
-          </a:xfrm>
-          <a:prstGeom prst="rect">
-            <a:avLst/>
-          </a:prstGeom>
-          <a:noFill/>
-        </p:spPr>
-        <p:txBody>
-          <a:bodyPr wrap="square" lIns="0" rIns="0" tIns="0" bIns="0">
-            <a:spAutoFit/>
-          </a:bodyPr>
-          <a:lstStyle/>
-          <a:p>
-            <a:pPr>
-              <a:spcAft>
-                <a:spcPts val="500"/>
-              </a:spcAft>
-              <a:defRPr sz="2100" b="0">
-                <a:solidFill>
-                  <a:srgbClr val="414F60"/>
-                </a:solidFill>
-                <a:latin typeface="Liberation Sans"/>
-              </a:defRPr>
-            </a:pPr>
-            <a:r>
-              <a:t>How do roles and replicas reach the scheduler?</a:t>
-            </a:r>
-          </a:p>
-        </p:txBody>
-      </p:sp>
-      <p:sp>
-        <p:nvSpPr>
-          <p:cNvPr id="9" name="TextBox 8"/>
-          <p:cNvSpPr txBox="1"/>
-          <p:nvPr/>
-        </p:nvSpPr>
-        <p:spPr>
-          <a:xfrm>
-            <a:off x="8503920" y="1554480"/>
-            <a:ext cx="3154680" cy="621792"/>
-          </a:xfrm>
-          <a:prstGeom prst="rect">
-            <a:avLst/>
-          </a:prstGeom>
-          <a:noFill/>
-        </p:spPr>
-        <p:txBody>
-          <a:bodyPr wrap="square" lIns="0" rIns="0" tIns="0" bIns="0">
-            <a:spAutoFit/>
-          </a:bodyPr>
-          <a:lstStyle/>
-          <a:p>
-            <a:pPr>
-              <a:spcAft>
-                <a:spcPts val="500"/>
-              </a:spcAft>
-              <a:defRPr sz="1500" b="0">
-                <a:solidFill>
-                  <a:srgbClr val="414F60"/>
-                </a:solidFill>
-                <a:latin typeface="Liberation Sans"/>
-              </a:defRPr>
-            </a:pPr>
-            <a:r>
-              <a:t>01  Unified scheduling</a:t>
-            </a:r>
-          </a:p>
-        </p:txBody>
-      </p:sp>
-      <p:sp>
-        <p:nvSpPr>
-          <p:cNvPr id="10" name="TextBox 9"/>
-          <p:cNvSpPr txBox="1"/>
-          <p:nvPr/>
-        </p:nvSpPr>
-        <p:spPr>
-          <a:xfrm>
-            <a:off x="8503920" y="2249424"/>
-            <a:ext cx="3154680" cy="621792"/>
-          </a:xfrm>
-          <a:prstGeom prst="rect">
-            <a:avLst/>
-          </a:prstGeom>
-          <a:noFill/>
-        </p:spPr>
-        <p:txBody>
-          <a:bodyPr wrap="square" lIns="0" rIns="0" tIns="0" bIns="0">
-            <a:spAutoFit/>
-          </a:bodyPr>
-          <a:lstStyle/>
-          <a:p>
-            <a:pPr>
-              <a:spcAft>
-                <a:spcPts val="500"/>
-              </a:spcAft>
-              <a:defRPr sz="1500" b="0">
-                <a:solidFill>
-                  <a:srgbClr val="414F60"/>
-                </a:solidFill>
-                <a:latin typeface="Liberation Sans"/>
-              </a:defRPr>
-            </a:pPr>
-            <a:r>
-              <a:t>02  Multi-level gang &amp; network topology</a:t>
-            </a:r>
-          </a:p>
-        </p:txBody>
-      </p:sp>
-      <p:sp>
-        <p:nvSpPr>
-          <p:cNvPr id="11" name="TextBox 10"/>
-          <p:cNvSpPr txBox="1"/>
-          <p:nvPr/>
-        </p:nvSpPr>
-        <p:spPr>
-          <a:xfrm>
-            <a:off x="8503920" y="2944368"/>
-            <a:ext cx="3154680" cy="621792"/>
-          </a:xfrm>
-          <a:prstGeom prst="rect">
-            <a:avLst/>
-          </a:prstGeom>
-          <a:noFill/>
-        </p:spPr>
-        <p:txBody>
-          <a:bodyPr wrap="square" lIns="0" rIns="0" tIns="0" bIns="0">
-            <a:spAutoFit/>
-          </a:bodyPr>
-          <a:lstStyle/>
-          <a:p>
-            <a:pPr>
-              <a:spcAft>
-                <a:spcPts val="500"/>
-              </a:spcAft>
-              <a:defRPr sz="1500" b="1">
-                <a:solidFill>
-                  <a:srgbClr val="164F89"/>
-                </a:solidFill>
-                <a:latin typeface="Liberation Sans"/>
-              </a:defRPr>
-            </a:pPr>
-            <a:r>
-              <a:t>03  Ecosystem</a:t>
-            </a:r>
-          </a:p>
-        </p:txBody>
-      </p:sp>
-      <p:sp>
-        <p:nvSpPr>
-          <p:cNvPr id="12" name="TextBox 11"/>
-          <p:cNvSpPr txBox="1"/>
-          <p:nvPr/>
-        </p:nvSpPr>
-        <p:spPr>
-          <a:xfrm>
-            <a:off x="8503920" y="3639312"/>
-            <a:ext cx="3154680" cy="621792"/>
-          </a:xfrm>
-          <a:prstGeom prst="rect">
-            <a:avLst/>
-          </a:prstGeom>
-          <a:noFill/>
-        </p:spPr>
-        <p:txBody>
-          <a:bodyPr wrap="square" lIns="0" rIns="0" tIns="0" bIns="0">
-            <a:spAutoFit/>
-          </a:bodyPr>
-          <a:lstStyle/>
-          <a:p>
-            <a:pPr>
-              <a:spcAft>
-                <a:spcPts val="500"/>
-              </a:spcAft>
-              <a:defRPr sz="1500" b="0">
-                <a:solidFill>
-                  <a:srgbClr val="414F60"/>
-                </a:solidFill>
-                <a:latin typeface="Liberation Sans"/>
-              </a:defRPr>
-            </a:pPr>
-            <a:r>
-              <a:t>04  Benchmark framework &amp; progress</a:t>
-            </a:r>
-          </a:p>
-        </p:txBody>
-      </p:sp>
-      <p:sp>
-        <p:nvSpPr>
-          <p:cNvPr id="13" name="TextBox 12"/>
           <p:cNvSpPr txBox="1"/>
           <p:nvPr/>
         </p:nvSpPr>
@@ -6904,7 +6801,7 @@
       </p:sp>
       <p:sp>
         <p:nvSpPr>
-          <p:cNvPr id="14" name="TextBox 13"/>
+          <p:cNvPr id="9" name="TextBox 8"/>
           <p:cNvSpPr txBox="1"/>
           <p:nvPr/>
         </p:nvSpPr>
@@ -6936,7 +6833,7 @@
               </a:defRPr>
             </a:pPr>
             <a:r>
-              <a:t>12 / 22</a:t>
+              <a:t>12 / 23</a:t>
             </a:r>
           </a:p>
         </p:txBody>
@@ -6961,7 +6858,7 @@
       <p:grpSpPr/>
       <p:pic>
         <p:nvPicPr>
-          <p:cNvPr id="2" name="Picture 1" descr="background.png"/>
+          <p:cNvPr id="2" name="Picture 1" descr="cover-background.png"/>
           <p:cNvPicPr>
             <a:picLocks noChangeAspect="1"/>
           </p:cNvPicPr>
@@ -7054,8 +6951,8 @@
         </p:nvSpPr>
         <p:spPr>
           <a:xfrm>
-            <a:off x="457200" y="804672"/>
-            <a:ext cx="11247120" cy="640080"/>
+            <a:off x="594360" y="1298448"/>
+            <a:ext cx="1828800" cy="640080"/>
           </a:xfrm>
           <a:prstGeom prst="rect">
             <a:avLst/>
@@ -7072,7 +6969,46 @@
               <a:spcAft>
                 <a:spcPts val="500"/>
               </a:spcAft>
-              <a:defRPr sz="3100" b="1">
+              <a:defRPr sz="3800" b="1">
+                <a:solidFill>
+                  <a:srgbClr val="164F89"/>
+                </a:solidFill>
+                <a:latin typeface="Liberation Sans"/>
+              </a:defRPr>
+            </a:pPr>
+            <a:r>
+              <a:t>03</a:t>
+            </a:r>
+          </a:p>
+        </p:txBody>
+      </p:sp>
+      <p:sp>
+        <p:nvSpPr>
+          <p:cNvPr id="6" name="TextBox 5"/>
+          <p:cNvSpPr txBox="1"/>
+          <p:nvPr/>
+        </p:nvSpPr>
+        <p:spPr>
+          <a:xfrm>
+            <a:off x="594360" y="2084831"/>
+            <a:ext cx="7863840" cy="1508760"/>
+          </a:xfrm>
+          <a:prstGeom prst="rect">
+            <a:avLst/>
+          </a:prstGeom>
+          <a:noFill/>
+        </p:spPr>
+        <p:txBody>
+          <a:bodyPr wrap="square" lIns="0" rIns="0" tIns="0" bIns="0">
+            <a:spAutoFit/>
+          </a:bodyPr>
+          <a:lstStyle/>
+          <a:p>
+            <a:pPr>
+              <a:spcAft>
+                <a:spcPts val="500"/>
+              </a:spcAft>
+              <a:defRPr sz="4100" b="1">
                 <a:solidFill>
                   <a:srgbClr val="17283B"/>
                 </a:solidFill>
@@ -7080,21 +7016,21 @@
               </a:defRPr>
             </a:pPr>
             <a:r>
-              <a:t>Controllers Bring Workload Structure to Scheduling</a:t>
-            </a:r>
-          </a:p>
-        </p:txBody>
-      </p:sp>
-      <p:sp>
-        <p:nvSpPr>
-          <p:cNvPr id="6" name="TextBox 5"/>
-          <p:cNvSpPr txBox="1"/>
-          <p:nvPr/>
-        </p:nvSpPr>
-        <p:spPr>
-          <a:xfrm>
-            <a:off x="475488" y="1435608"/>
-            <a:ext cx="11201400" cy="429768"/>
+              <a:t>Ecosystem</a:t>
+            </a:r>
+          </a:p>
+        </p:txBody>
+      </p:sp>
+      <p:sp>
+        <p:nvSpPr>
+          <p:cNvPr id="7" name="TextBox 6"/>
+          <p:cNvSpPr txBox="1"/>
+          <p:nvPr/>
+        </p:nvSpPr>
+        <p:spPr>
+          <a:xfrm>
+            <a:off x="621792" y="4041648"/>
+            <a:ext cx="9966960" cy="548640"/>
           </a:xfrm>
           <a:prstGeom prst="rect">
             <a:avLst/>
@@ -7111,7 +7047,46 @@
               <a:spcAft>
                 <a:spcPts val="500"/>
               </a:spcAft>
-              <a:defRPr sz="1700" b="0">
+              <a:defRPr sz="2400" b="0">
+                <a:solidFill>
+                  <a:srgbClr val="164F89"/>
+                </a:solidFill>
+                <a:latin typeface="Liberation Sans"/>
+              </a:defRPr>
+            </a:pPr>
+            <a:r>
+              <a:t>Workload controllers carry scheduling intent.</a:t>
+            </a:r>
+          </a:p>
+        </p:txBody>
+      </p:sp>
+      <p:sp>
+        <p:nvSpPr>
+          <p:cNvPr id="8" name="TextBox 7"/>
+          <p:cNvSpPr txBox="1"/>
+          <p:nvPr/>
+        </p:nvSpPr>
+        <p:spPr>
+          <a:xfrm>
+            <a:off x="621792" y="4791456"/>
+            <a:ext cx="10607040" cy="594360"/>
+          </a:xfrm>
+          <a:prstGeom prst="rect">
+            <a:avLst/>
+          </a:prstGeom>
+          <a:noFill/>
+        </p:spPr>
+        <p:txBody>
+          <a:bodyPr wrap="square" lIns="0" rIns="0" tIns="0" bIns="0">
+            <a:spAutoFit/>
+          </a:bodyPr>
+          <a:lstStyle/>
+          <a:p>
+            <a:pPr>
+              <a:spcAft>
+                <a:spcPts val="500"/>
+              </a:spcAft>
+              <a:defRPr sz="2100" b="0">
                 <a:solidFill>
                   <a:srgbClr val="414F60"/>
                 </a:solidFill>
@@ -7119,38 +7094,170 @@
               </a:defRPr>
             </a:pPr>
             <a:r>
-              <a:t>Existing integrations and the next steps in role, replica, and topology support.</a:t>
-            </a:r>
-          </a:p>
-        </p:txBody>
-      </p:sp>
-      <p:pic>
-        <p:nvPicPr>
-          <p:cNvPr id="7" name="Picture 6" descr="13-ecosystem.png"/>
-          <p:cNvPicPr>
-            <a:picLocks noChangeAspect="1"/>
-          </p:cNvPicPr>
-          <p:nvPr/>
-        </p:nvPicPr>
-        <p:blipFill>
-          <a:blip r:embed="rId4"/>
-          <a:stretch>
-            <a:fillRect/>
-          </a:stretch>
-        </p:blipFill>
-        <p:spPr>
-          <a:xfrm>
-            <a:off x="457200" y="1938528"/>
-            <a:ext cx="11277599" cy="4267200"/>
-          </a:xfrm>
-          <a:prstGeom prst="rect">
-            <a:avLst/>
-          </a:prstGeom>
-        </p:spPr>
-      </p:pic>
-      <p:sp>
-        <p:nvSpPr>
-          <p:cNvPr id="8" name="TextBox 7"/>
+              <a:t>How do roles and replicas reach the scheduler?</a:t>
+            </a:r>
+          </a:p>
+        </p:txBody>
+      </p:sp>
+      <p:sp>
+        <p:nvSpPr>
+          <p:cNvPr id="9" name="TextBox 8"/>
+          <p:cNvSpPr txBox="1"/>
+          <p:nvPr/>
+        </p:nvSpPr>
+        <p:spPr>
+          <a:xfrm>
+            <a:off x="8503920" y="1554480"/>
+            <a:ext cx="3154680" cy="621792"/>
+          </a:xfrm>
+          <a:prstGeom prst="rect">
+            <a:avLst/>
+          </a:prstGeom>
+          <a:noFill/>
+        </p:spPr>
+        <p:txBody>
+          <a:bodyPr wrap="square" lIns="0" rIns="0" tIns="0" bIns="0">
+            <a:spAutoFit/>
+          </a:bodyPr>
+          <a:lstStyle/>
+          <a:p>
+            <a:pPr>
+              <a:spcAft>
+                <a:spcPts val="500"/>
+              </a:spcAft>
+              <a:defRPr sz="1500" b="0">
+                <a:solidFill>
+                  <a:srgbClr val="414F60"/>
+                </a:solidFill>
+                <a:latin typeface="Liberation Sans"/>
+              </a:defRPr>
+            </a:pPr>
+            <a:r>
+              <a:t>01  Unified scheduling</a:t>
+            </a:r>
+          </a:p>
+        </p:txBody>
+      </p:sp>
+      <p:sp>
+        <p:nvSpPr>
+          <p:cNvPr id="10" name="TextBox 9"/>
+          <p:cNvSpPr txBox="1"/>
+          <p:nvPr/>
+        </p:nvSpPr>
+        <p:spPr>
+          <a:xfrm>
+            <a:off x="8503920" y="2249424"/>
+            <a:ext cx="3154680" cy="621792"/>
+          </a:xfrm>
+          <a:prstGeom prst="rect">
+            <a:avLst/>
+          </a:prstGeom>
+          <a:noFill/>
+        </p:spPr>
+        <p:txBody>
+          <a:bodyPr wrap="square" lIns="0" rIns="0" tIns="0" bIns="0">
+            <a:spAutoFit/>
+          </a:bodyPr>
+          <a:lstStyle/>
+          <a:p>
+            <a:pPr>
+              <a:spcAft>
+                <a:spcPts val="500"/>
+              </a:spcAft>
+              <a:defRPr sz="1500" b="0">
+                <a:solidFill>
+                  <a:srgbClr val="414F60"/>
+                </a:solidFill>
+                <a:latin typeface="Liberation Sans"/>
+              </a:defRPr>
+            </a:pPr>
+            <a:r>
+              <a:t>02  Multi-level gang &amp; network topology</a:t>
+            </a:r>
+          </a:p>
+        </p:txBody>
+      </p:sp>
+      <p:sp>
+        <p:nvSpPr>
+          <p:cNvPr id="11" name="TextBox 10"/>
+          <p:cNvSpPr txBox="1"/>
+          <p:nvPr/>
+        </p:nvSpPr>
+        <p:spPr>
+          <a:xfrm>
+            <a:off x="8503920" y="2944368"/>
+            <a:ext cx="3154680" cy="621792"/>
+          </a:xfrm>
+          <a:prstGeom prst="rect">
+            <a:avLst/>
+          </a:prstGeom>
+          <a:noFill/>
+        </p:spPr>
+        <p:txBody>
+          <a:bodyPr wrap="square" lIns="0" rIns="0" tIns="0" bIns="0">
+            <a:spAutoFit/>
+          </a:bodyPr>
+          <a:lstStyle/>
+          <a:p>
+            <a:pPr>
+              <a:spcAft>
+                <a:spcPts val="500"/>
+              </a:spcAft>
+              <a:defRPr sz="1500" b="1">
+                <a:solidFill>
+                  <a:srgbClr val="164F89"/>
+                </a:solidFill>
+                <a:latin typeface="Liberation Sans"/>
+              </a:defRPr>
+            </a:pPr>
+            <a:r>
+              <a:t>03  Ecosystem</a:t>
+            </a:r>
+          </a:p>
+        </p:txBody>
+      </p:sp>
+      <p:sp>
+        <p:nvSpPr>
+          <p:cNvPr id="12" name="TextBox 11"/>
+          <p:cNvSpPr txBox="1"/>
+          <p:nvPr/>
+        </p:nvSpPr>
+        <p:spPr>
+          <a:xfrm>
+            <a:off x="8503920" y="3639312"/>
+            <a:ext cx="3154680" cy="621792"/>
+          </a:xfrm>
+          <a:prstGeom prst="rect">
+            <a:avLst/>
+          </a:prstGeom>
+          <a:noFill/>
+        </p:spPr>
+        <p:txBody>
+          <a:bodyPr wrap="square" lIns="0" rIns="0" tIns="0" bIns="0">
+            <a:spAutoFit/>
+          </a:bodyPr>
+          <a:lstStyle/>
+          <a:p>
+            <a:pPr>
+              <a:spcAft>
+                <a:spcPts val="500"/>
+              </a:spcAft>
+              <a:defRPr sz="1500" b="0">
+                <a:solidFill>
+                  <a:srgbClr val="414F60"/>
+                </a:solidFill>
+                <a:latin typeface="Liberation Sans"/>
+              </a:defRPr>
+            </a:pPr>
+            <a:r>
+              <a:t>04  Benchmark framework &amp; progress</a:t>
+            </a:r>
+          </a:p>
+        </p:txBody>
+      </p:sp>
+      <p:sp>
+        <p:nvSpPr>
+          <p:cNvPr id="13" name="TextBox 12"/>
           <p:cNvSpPr txBox="1"/>
           <p:nvPr/>
         </p:nvSpPr>
@@ -7189,7 +7296,7 @@
       </p:sp>
       <p:sp>
         <p:nvSpPr>
-          <p:cNvPr id="9" name="TextBox 8"/>
+          <p:cNvPr id="14" name="TextBox 13"/>
           <p:cNvSpPr txBox="1"/>
           <p:nvPr/>
         </p:nvSpPr>
@@ -7221,7 +7328,7 @@
               </a:defRPr>
             </a:pPr>
             <a:r>
-              <a:t>13 / 22</a:t>
+              <a:t>13 / 23</a:t>
             </a:r>
           </a:p>
         </p:txBody>
@@ -7506,7 +7613,7 @@
               </a:defRPr>
             </a:pPr>
             <a:r>
-              <a:t>14 / 22</a:t>
+              <a:t>14 / 23</a:t>
             </a:r>
           </a:p>
         </p:txBody>
@@ -7791,7 +7898,7 @@
               </a:defRPr>
             </a:pPr>
             <a:r>
-              <a:t>15 / 22</a:t>
+              <a:t>15 / 23</a:t>
             </a:r>
           </a:p>
         </p:txBody>
@@ -7935,7 +8042,7 @@
               </a:defRPr>
             </a:pPr>
             <a:r>
-              <a:t>Next: Relationships Between SubGroups</a:t>
+              <a:t>Grove: Carry PodGang Structure into Volcano</a:t>
             </a:r>
           </a:p>
         </p:txBody>
@@ -7974,14 +8081,14 @@
               </a:defRPr>
             </a:pPr>
             <a:r>
-              <a:t>Extend the placement model as controllers expose richer workload structure.</a:t>
+              <a:t>The backend translates Grove PodGroups into Volcano SubGroup policies.</a:t>
             </a:r>
           </a:p>
         </p:txBody>
       </p:sp>
       <p:pic>
         <p:nvPicPr>
-          <p:cNvPr id="7" name="Picture 6" descr="16-subgroup-next.png"/>
+          <p:cNvPr id="7" name="Picture 6" descr="16-grove-mapping.png"/>
           <p:cNvPicPr>
             <a:picLocks noChangeAspect="1"/>
           </p:cNvPicPr>
@@ -8076,7 +8183,7 @@
               </a:defRPr>
             </a:pPr>
             <a:r>
-              <a:t>16 / 22</a:t>
+              <a:t>16 / 23</a:t>
             </a:r>
           </a:p>
         </p:txBody>
@@ -8101,7 +8208,7 @@
       <p:grpSpPr/>
       <p:pic>
         <p:nvPicPr>
-          <p:cNvPr id="2" name="Picture 1" descr="cover-background.png"/>
+          <p:cNvPr id="2" name="Picture 1" descr="background.png"/>
           <p:cNvPicPr>
             <a:picLocks noChangeAspect="1"/>
           </p:cNvPicPr>
@@ -8181,7 +8288,7 @@
               </a:defRPr>
             </a:pPr>
             <a:r>
-              <a:t>BENCHMARK FRAMEWORK &amp; PROGRESS</a:t>
+              <a:t>ECOSYSTEM</a:t>
             </a:r>
           </a:p>
         </p:txBody>
@@ -8194,8 +8301,8 @@
         </p:nvSpPr>
         <p:spPr>
           <a:xfrm>
-            <a:off x="594360" y="1298448"/>
-            <a:ext cx="1828800" cy="640080"/>
+            <a:off x="457200" y="804672"/>
+            <a:ext cx="11247120" cy="640080"/>
           </a:xfrm>
           <a:prstGeom prst="rect">
             <a:avLst/>
@@ -8212,15 +8319,15 @@
               <a:spcAft>
                 <a:spcPts val="500"/>
               </a:spcAft>
-              <a:defRPr sz="3800" b="1">
-                <a:solidFill>
-                  <a:srgbClr val="164F89"/>
-                </a:solidFill>
-                <a:latin typeface="Liberation Sans"/>
-              </a:defRPr>
-            </a:pPr>
-            <a:r>
-              <a:t>04</a:t>
+              <a:defRPr sz="3100" b="1">
+                <a:solidFill>
+                  <a:srgbClr val="17283B"/>
+                </a:solidFill>
+                <a:latin typeface="Liberation Sans"/>
+              </a:defRPr>
+            </a:pPr>
+            <a:r>
+              <a:t>Next: RBG, Kubeflow, and LWS</a:t>
             </a:r>
           </a:p>
         </p:txBody>
@@ -8233,8 +8340,8 @@
         </p:nvSpPr>
         <p:spPr>
           <a:xfrm>
-            <a:off x="594360" y="2084831"/>
-            <a:ext cx="7863840" cy="1508760"/>
+            <a:off x="475488" y="1435608"/>
+            <a:ext cx="11201400" cy="429768"/>
           </a:xfrm>
           <a:prstGeom prst="rect">
             <a:avLst/>
@@ -8251,272 +8358,46 @@
               <a:spcAft>
                 <a:spcPts val="500"/>
               </a:spcAft>
-              <a:defRPr sz="4100" b="1">
-                <a:solidFill>
-                  <a:srgbClr val="17283B"/>
-                </a:solidFill>
-                <a:latin typeface="Liberation Sans"/>
-              </a:defRPr>
-            </a:pPr>
-            <a:r>
-              <a:t>Benchmark</a:t>
-            </a:r>
-          </a:p>
-          <a:p>
-            <a:pPr>
-              <a:spcAft>
-                <a:spcPts val="500"/>
-              </a:spcAft>
-              <a:defRPr sz="4100" b="1">
-                <a:solidFill>
-                  <a:srgbClr val="17283B"/>
-                </a:solidFill>
-                <a:latin typeface="Liberation Sans"/>
-              </a:defRPr>
-            </a:pPr>
-            <a:r>
-              <a:t>framework &amp; progress</a:t>
-            </a:r>
-          </a:p>
-        </p:txBody>
-      </p:sp>
-      <p:sp>
-        <p:nvSpPr>
-          <p:cNvPr id="7" name="TextBox 6"/>
-          <p:cNvSpPr txBox="1"/>
-          <p:nvPr/>
-        </p:nvSpPr>
-        <p:spPr>
-          <a:xfrm>
-            <a:off x="621792" y="4041648"/>
-            <a:ext cx="9966960" cy="548640"/>
-          </a:xfrm>
-          <a:prstGeom prst="rect">
-            <a:avLst/>
-          </a:prstGeom>
-          <a:noFill/>
-        </p:spPr>
-        <p:txBody>
-          <a:bodyPr wrap="square" lIns="0" rIns="0" tIns="0" bIns="0">
-            <a:spAutoFit/>
-          </a:bodyPr>
-          <a:lstStyle/>
-          <a:p>
-            <a:pPr>
-              <a:spcAft>
-                <a:spcPts val="500"/>
-              </a:spcAft>
-              <a:defRPr sz="2400" b="0">
-                <a:solidFill>
-                  <a:srgbClr val="164F89"/>
-                </a:solidFill>
-                <a:latin typeface="Liberation Sans"/>
-              </a:defRPr>
-            </a:pPr>
-            <a:r>
-              <a:t>Measure behavior across workload shapes.</a:t>
-            </a:r>
-          </a:p>
-        </p:txBody>
-      </p:sp>
+              <a:defRPr sz="1700" b="0">
+                <a:solidFill>
+                  <a:srgbClr val="414F60"/>
+                </a:solidFill>
+                <a:latin typeface="Liberation Sans"/>
+              </a:defRPr>
+            </a:pPr>
+            <a:r>
+              <a:t>Build on current integrations; carry finer group structure and placement requirements.</a:t>
+            </a:r>
+          </a:p>
+        </p:txBody>
+      </p:sp>
+      <p:pic>
+        <p:nvPicPr>
+          <p:cNvPr id="7" name="Picture 6" descr="17-ecosystem.png"/>
+          <p:cNvPicPr>
+            <a:picLocks noChangeAspect="1"/>
+          </p:cNvPicPr>
+          <p:nvPr/>
+        </p:nvPicPr>
+        <p:blipFill>
+          <a:blip r:embed="rId4"/>
+          <a:stretch>
+            <a:fillRect/>
+          </a:stretch>
+        </p:blipFill>
+        <p:spPr>
+          <a:xfrm>
+            <a:off x="457200" y="1938528"/>
+            <a:ext cx="11277599" cy="4267200"/>
+          </a:xfrm>
+          <a:prstGeom prst="rect">
+            <a:avLst/>
+          </a:prstGeom>
+        </p:spPr>
+      </p:pic>
       <p:sp>
         <p:nvSpPr>
           <p:cNvPr id="8" name="TextBox 7"/>
-          <p:cNvSpPr txBox="1"/>
-          <p:nvPr/>
-        </p:nvSpPr>
-        <p:spPr>
-          <a:xfrm>
-            <a:off x="621792" y="4791456"/>
-            <a:ext cx="10607040" cy="594360"/>
-          </a:xfrm>
-          <a:prstGeom prst="rect">
-            <a:avLst/>
-          </a:prstGeom>
-          <a:noFill/>
-        </p:spPr>
-        <p:txBody>
-          <a:bodyPr wrap="square" lIns="0" rIns="0" tIns="0" bIns="0">
-            <a:spAutoFit/>
-          </a:bodyPr>
-          <a:lstStyle/>
-          <a:p>
-            <a:pPr>
-              <a:spcAft>
-                <a:spcPts val="500"/>
-              </a:spcAft>
-              <a:defRPr sz="2100" b="0">
-                <a:solidFill>
-                  <a:srgbClr val="414F60"/>
-                </a:solidFill>
-                <a:latin typeface="Liberation Sans"/>
-              </a:defRPr>
-            </a:pPr>
-            <a:r>
-              <a:t>What can we reproduce, compare, and improve?</a:t>
-            </a:r>
-          </a:p>
-        </p:txBody>
-      </p:sp>
-      <p:sp>
-        <p:nvSpPr>
-          <p:cNvPr id="9" name="TextBox 8"/>
-          <p:cNvSpPr txBox="1"/>
-          <p:nvPr/>
-        </p:nvSpPr>
-        <p:spPr>
-          <a:xfrm>
-            <a:off x="8503920" y="1554480"/>
-            <a:ext cx="3154680" cy="621792"/>
-          </a:xfrm>
-          <a:prstGeom prst="rect">
-            <a:avLst/>
-          </a:prstGeom>
-          <a:noFill/>
-        </p:spPr>
-        <p:txBody>
-          <a:bodyPr wrap="square" lIns="0" rIns="0" tIns="0" bIns="0">
-            <a:spAutoFit/>
-          </a:bodyPr>
-          <a:lstStyle/>
-          <a:p>
-            <a:pPr>
-              <a:spcAft>
-                <a:spcPts val="500"/>
-              </a:spcAft>
-              <a:defRPr sz="1500" b="0">
-                <a:solidFill>
-                  <a:srgbClr val="414F60"/>
-                </a:solidFill>
-                <a:latin typeface="Liberation Sans"/>
-              </a:defRPr>
-            </a:pPr>
-            <a:r>
-              <a:t>01  Unified scheduling</a:t>
-            </a:r>
-          </a:p>
-        </p:txBody>
-      </p:sp>
-      <p:sp>
-        <p:nvSpPr>
-          <p:cNvPr id="10" name="TextBox 9"/>
-          <p:cNvSpPr txBox="1"/>
-          <p:nvPr/>
-        </p:nvSpPr>
-        <p:spPr>
-          <a:xfrm>
-            <a:off x="8503920" y="2249424"/>
-            <a:ext cx="3154680" cy="621792"/>
-          </a:xfrm>
-          <a:prstGeom prst="rect">
-            <a:avLst/>
-          </a:prstGeom>
-          <a:noFill/>
-        </p:spPr>
-        <p:txBody>
-          <a:bodyPr wrap="square" lIns="0" rIns="0" tIns="0" bIns="0">
-            <a:spAutoFit/>
-          </a:bodyPr>
-          <a:lstStyle/>
-          <a:p>
-            <a:pPr>
-              <a:spcAft>
-                <a:spcPts val="500"/>
-              </a:spcAft>
-              <a:defRPr sz="1500" b="0">
-                <a:solidFill>
-                  <a:srgbClr val="414F60"/>
-                </a:solidFill>
-                <a:latin typeface="Liberation Sans"/>
-              </a:defRPr>
-            </a:pPr>
-            <a:r>
-              <a:t>02  Multi-level gang &amp; network topology</a:t>
-            </a:r>
-          </a:p>
-        </p:txBody>
-      </p:sp>
-      <p:sp>
-        <p:nvSpPr>
-          <p:cNvPr id="11" name="TextBox 10"/>
-          <p:cNvSpPr txBox="1"/>
-          <p:nvPr/>
-        </p:nvSpPr>
-        <p:spPr>
-          <a:xfrm>
-            <a:off x="8503920" y="2944368"/>
-            <a:ext cx="3154680" cy="621792"/>
-          </a:xfrm>
-          <a:prstGeom prst="rect">
-            <a:avLst/>
-          </a:prstGeom>
-          <a:noFill/>
-        </p:spPr>
-        <p:txBody>
-          <a:bodyPr wrap="square" lIns="0" rIns="0" tIns="0" bIns="0">
-            <a:spAutoFit/>
-          </a:bodyPr>
-          <a:lstStyle/>
-          <a:p>
-            <a:pPr>
-              <a:spcAft>
-                <a:spcPts val="500"/>
-              </a:spcAft>
-              <a:defRPr sz="1500" b="0">
-                <a:solidFill>
-                  <a:srgbClr val="414F60"/>
-                </a:solidFill>
-                <a:latin typeface="Liberation Sans"/>
-              </a:defRPr>
-            </a:pPr>
-            <a:r>
-              <a:t>03  Ecosystem</a:t>
-            </a:r>
-          </a:p>
-        </p:txBody>
-      </p:sp>
-      <p:sp>
-        <p:nvSpPr>
-          <p:cNvPr id="12" name="TextBox 11"/>
-          <p:cNvSpPr txBox="1"/>
-          <p:nvPr/>
-        </p:nvSpPr>
-        <p:spPr>
-          <a:xfrm>
-            <a:off x="8503920" y="3639312"/>
-            <a:ext cx="3154680" cy="621792"/>
-          </a:xfrm>
-          <a:prstGeom prst="rect">
-            <a:avLst/>
-          </a:prstGeom>
-          <a:noFill/>
-        </p:spPr>
-        <p:txBody>
-          <a:bodyPr wrap="square" lIns="0" rIns="0" tIns="0" bIns="0">
-            <a:spAutoFit/>
-          </a:bodyPr>
-          <a:lstStyle/>
-          <a:p>
-            <a:pPr>
-              <a:spcAft>
-                <a:spcPts val="500"/>
-              </a:spcAft>
-              <a:defRPr sz="1500" b="1">
-                <a:solidFill>
-                  <a:srgbClr val="164F89"/>
-                </a:solidFill>
-                <a:latin typeface="Liberation Sans"/>
-              </a:defRPr>
-            </a:pPr>
-            <a:r>
-              <a:t>04  Benchmark framework &amp; progress</a:t>
-            </a:r>
-          </a:p>
-        </p:txBody>
-      </p:sp>
-      <p:sp>
-        <p:nvSpPr>
-          <p:cNvPr id="13" name="TextBox 12"/>
           <p:cNvSpPr txBox="1"/>
           <p:nvPr/>
         </p:nvSpPr>
@@ -8555,7 +8436,7 @@
       </p:sp>
       <p:sp>
         <p:nvSpPr>
-          <p:cNvPr id="14" name="TextBox 13"/>
+          <p:cNvPr id="9" name="TextBox 8"/>
           <p:cNvSpPr txBox="1"/>
           <p:nvPr/>
         </p:nvSpPr>
@@ -8587,7 +8468,7 @@
               </a:defRPr>
             </a:pPr>
             <a:r>
-              <a:t>17 / 22</a:t>
+              <a:t>17 / 23</a:t>
             </a:r>
           </a:p>
         </p:txBody>
@@ -8612,7 +8493,7 @@
       <p:grpSpPr/>
       <p:pic>
         <p:nvPicPr>
-          <p:cNvPr id="2" name="Picture 1" descr="background.png"/>
+          <p:cNvPr id="2" name="Picture 1" descr="cover-background.png"/>
           <p:cNvPicPr>
             <a:picLocks noChangeAspect="1"/>
           </p:cNvPicPr>
@@ -8705,8 +8586,8 @@
         </p:nvSpPr>
         <p:spPr>
           <a:xfrm>
-            <a:off x="457200" y="804672"/>
-            <a:ext cx="11247120" cy="640080"/>
+            <a:off x="594360" y="1298448"/>
+            <a:ext cx="1828800" cy="640080"/>
           </a:xfrm>
           <a:prstGeom prst="rect">
             <a:avLst/>
@@ -8723,7 +8604,46 @@
               <a:spcAft>
                 <a:spcPts val="500"/>
               </a:spcAft>
-              <a:defRPr sz="3100" b="1">
+              <a:defRPr sz="3800" b="1">
+                <a:solidFill>
+                  <a:srgbClr val="164F89"/>
+                </a:solidFill>
+                <a:latin typeface="Liberation Sans"/>
+              </a:defRPr>
+            </a:pPr>
+            <a:r>
+              <a:t>04</a:t>
+            </a:r>
+          </a:p>
+        </p:txBody>
+      </p:sp>
+      <p:sp>
+        <p:nvSpPr>
+          <p:cNvPr id="6" name="TextBox 5"/>
+          <p:cNvSpPr txBox="1"/>
+          <p:nvPr/>
+        </p:nvSpPr>
+        <p:spPr>
+          <a:xfrm>
+            <a:off x="594360" y="2084831"/>
+            <a:ext cx="7863840" cy="1508760"/>
+          </a:xfrm>
+          <a:prstGeom prst="rect">
+            <a:avLst/>
+          </a:prstGeom>
+          <a:noFill/>
+        </p:spPr>
+        <p:txBody>
+          <a:bodyPr wrap="square" lIns="0" rIns="0" tIns="0" bIns="0">
+            <a:spAutoFit/>
+          </a:bodyPr>
+          <a:lstStyle/>
+          <a:p>
+            <a:pPr>
+              <a:spcAft>
+                <a:spcPts val="500"/>
+              </a:spcAft>
+              <a:defRPr sz="4100" b="1">
                 <a:solidFill>
                   <a:srgbClr val="17283B"/>
                 </a:solidFill>
@@ -8731,38 +8651,93 @@
               </a:defRPr>
             </a:pPr>
             <a:r>
-              <a:t>A Repeatable Scheduling Benchmark Framework</a:t>
-            </a:r>
-          </a:p>
-        </p:txBody>
-      </p:sp>
-      <p:sp>
-        <p:nvSpPr>
-          <p:cNvPr id="6" name="TextBox 5"/>
-          <p:cNvSpPr txBox="1"/>
-          <p:nvPr/>
-        </p:nvSpPr>
-        <p:spPr>
-          <a:xfrm>
-            <a:off x="475488" y="1435608"/>
-            <a:ext cx="11201400" cy="429768"/>
-          </a:xfrm>
-          <a:prstGeom prst="rect">
-            <a:avLst/>
-          </a:prstGeom>
-          <a:noFill/>
-        </p:spPr>
-        <p:txBody>
-          <a:bodyPr wrap="square" lIns="0" rIns="0" tIns="0" bIns="0">
-            <a:spAutoFit/>
-          </a:bodyPr>
-          <a:lstStyle/>
+              <a:t>Benchmark</a:t>
+            </a:r>
+          </a:p>
           <a:p>
             <a:pPr>
               <a:spcAft>
                 <a:spcPts val="500"/>
               </a:spcAft>
-              <a:defRPr sz="1700" b="0">
+              <a:defRPr sz="4100" b="1">
+                <a:solidFill>
+                  <a:srgbClr val="17283B"/>
+                </a:solidFill>
+                <a:latin typeface="Liberation Sans"/>
+              </a:defRPr>
+            </a:pPr>
+            <a:r>
+              <a:t>framework &amp; progress</a:t>
+            </a:r>
+          </a:p>
+        </p:txBody>
+      </p:sp>
+      <p:sp>
+        <p:nvSpPr>
+          <p:cNvPr id="7" name="TextBox 6"/>
+          <p:cNvSpPr txBox="1"/>
+          <p:nvPr/>
+        </p:nvSpPr>
+        <p:spPr>
+          <a:xfrm>
+            <a:off x="621792" y="4041648"/>
+            <a:ext cx="9966960" cy="548640"/>
+          </a:xfrm>
+          <a:prstGeom prst="rect">
+            <a:avLst/>
+          </a:prstGeom>
+          <a:noFill/>
+        </p:spPr>
+        <p:txBody>
+          <a:bodyPr wrap="square" lIns="0" rIns="0" tIns="0" bIns="0">
+            <a:spAutoFit/>
+          </a:bodyPr>
+          <a:lstStyle/>
+          <a:p>
+            <a:pPr>
+              <a:spcAft>
+                <a:spcPts val="500"/>
+              </a:spcAft>
+              <a:defRPr sz="2400" b="0">
+                <a:solidFill>
+                  <a:srgbClr val="164F89"/>
+                </a:solidFill>
+                <a:latin typeface="Liberation Sans"/>
+              </a:defRPr>
+            </a:pPr>
+            <a:r>
+              <a:t>Measure behavior across workload shapes.</a:t>
+            </a:r>
+          </a:p>
+        </p:txBody>
+      </p:sp>
+      <p:sp>
+        <p:nvSpPr>
+          <p:cNvPr id="8" name="TextBox 7"/>
+          <p:cNvSpPr txBox="1"/>
+          <p:nvPr/>
+        </p:nvSpPr>
+        <p:spPr>
+          <a:xfrm>
+            <a:off x="621792" y="4791456"/>
+            <a:ext cx="10607040" cy="594360"/>
+          </a:xfrm>
+          <a:prstGeom prst="rect">
+            <a:avLst/>
+          </a:prstGeom>
+          <a:noFill/>
+        </p:spPr>
+        <p:txBody>
+          <a:bodyPr wrap="square" lIns="0" rIns="0" tIns="0" bIns="0">
+            <a:spAutoFit/>
+          </a:bodyPr>
+          <a:lstStyle/>
+          <a:p>
+            <a:pPr>
+              <a:spcAft>
+                <a:spcPts val="500"/>
+              </a:spcAft>
+              <a:defRPr sz="2100" b="0">
                 <a:solidFill>
                   <a:srgbClr val="414F60"/>
                 </a:solidFill>
@@ -8770,38 +8745,170 @@
               </a:defRPr>
             </a:pPr>
             <a:r>
-              <a:t>Generate scenarios, observe API events, and retain comparable measurements.</a:t>
-            </a:r>
-          </a:p>
-        </p:txBody>
-      </p:sp>
-      <p:pic>
-        <p:nvPicPr>
-          <p:cNvPr id="7" name="Picture 6" descr="18-benchmark-architecture.png"/>
-          <p:cNvPicPr>
-            <a:picLocks noChangeAspect="1"/>
-          </p:cNvPicPr>
-          <p:nvPr/>
-        </p:nvPicPr>
-        <p:blipFill>
-          <a:blip r:embed="rId4"/>
-          <a:stretch>
-            <a:fillRect/>
-          </a:stretch>
-        </p:blipFill>
-        <p:spPr>
-          <a:xfrm>
-            <a:off x="457200" y="1938528"/>
-            <a:ext cx="11277599" cy="4267200"/>
-          </a:xfrm>
-          <a:prstGeom prst="rect">
-            <a:avLst/>
-          </a:prstGeom>
-        </p:spPr>
-      </p:pic>
-      <p:sp>
-        <p:nvSpPr>
-          <p:cNvPr id="8" name="TextBox 7"/>
+              <a:t>What can we reproduce, compare, and improve?</a:t>
+            </a:r>
+          </a:p>
+        </p:txBody>
+      </p:sp>
+      <p:sp>
+        <p:nvSpPr>
+          <p:cNvPr id="9" name="TextBox 8"/>
+          <p:cNvSpPr txBox="1"/>
+          <p:nvPr/>
+        </p:nvSpPr>
+        <p:spPr>
+          <a:xfrm>
+            <a:off x="8503920" y="1554480"/>
+            <a:ext cx="3154680" cy="621792"/>
+          </a:xfrm>
+          <a:prstGeom prst="rect">
+            <a:avLst/>
+          </a:prstGeom>
+          <a:noFill/>
+        </p:spPr>
+        <p:txBody>
+          <a:bodyPr wrap="square" lIns="0" rIns="0" tIns="0" bIns="0">
+            <a:spAutoFit/>
+          </a:bodyPr>
+          <a:lstStyle/>
+          <a:p>
+            <a:pPr>
+              <a:spcAft>
+                <a:spcPts val="500"/>
+              </a:spcAft>
+              <a:defRPr sz="1500" b="0">
+                <a:solidFill>
+                  <a:srgbClr val="414F60"/>
+                </a:solidFill>
+                <a:latin typeface="Liberation Sans"/>
+              </a:defRPr>
+            </a:pPr>
+            <a:r>
+              <a:t>01  Unified scheduling</a:t>
+            </a:r>
+          </a:p>
+        </p:txBody>
+      </p:sp>
+      <p:sp>
+        <p:nvSpPr>
+          <p:cNvPr id="10" name="TextBox 9"/>
+          <p:cNvSpPr txBox="1"/>
+          <p:nvPr/>
+        </p:nvSpPr>
+        <p:spPr>
+          <a:xfrm>
+            <a:off x="8503920" y="2249424"/>
+            <a:ext cx="3154680" cy="621792"/>
+          </a:xfrm>
+          <a:prstGeom prst="rect">
+            <a:avLst/>
+          </a:prstGeom>
+          <a:noFill/>
+        </p:spPr>
+        <p:txBody>
+          <a:bodyPr wrap="square" lIns="0" rIns="0" tIns="0" bIns="0">
+            <a:spAutoFit/>
+          </a:bodyPr>
+          <a:lstStyle/>
+          <a:p>
+            <a:pPr>
+              <a:spcAft>
+                <a:spcPts val="500"/>
+              </a:spcAft>
+              <a:defRPr sz="1500" b="0">
+                <a:solidFill>
+                  <a:srgbClr val="414F60"/>
+                </a:solidFill>
+                <a:latin typeface="Liberation Sans"/>
+              </a:defRPr>
+            </a:pPr>
+            <a:r>
+              <a:t>02  Multi-level gang &amp; network topology</a:t>
+            </a:r>
+          </a:p>
+        </p:txBody>
+      </p:sp>
+      <p:sp>
+        <p:nvSpPr>
+          <p:cNvPr id="11" name="TextBox 10"/>
+          <p:cNvSpPr txBox="1"/>
+          <p:nvPr/>
+        </p:nvSpPr>
+        <p:spPr>
+          <a:xfrm>
+            <a:off x="8503920" y="2944368"/>
+            <a:ext cx="3154680" cy="621792"/>
+          </a:xfrm>
+          <a:prstGeom prst="rect">
+            <a:avLst/>
+          </a:prstGeom>
+          <a:noFill/>
+        </p:spPr>
+        <p:txBody>
+          <a:bodyPr wrap="square" lIns="0" rIns="0" tIns="0" bIns="0">
+            <a:spAutoFit/>
+          </a:bodyPr>
+          <a:lstStyle/>
+          <a:p>
+            <a:pPr>
+              <a:spcAft>
+                <a:spcPts val="500"/>
+              </a:spcAft>
+              <a:defRPr sz="1500" b="0">
+                <a:solidFill>
+                  <a:srgbClr val="414F60"/>
+                </a:solidFill>
+                <a:latin typeface="Liberation Sans"/>
+              </a:defRPr>
+            </a:pPr>
+            <a:r>
+              <a:t>03  Ecosystem</a:t>
+            </a:r>
+          </a:p>
+        </p:txBody>
+      </p:sp>
+      <p:sp>
+        <p:nvSpPr>
+          <p:cNvPr id="12" name="TextBox 11"/>
+          <p:cNvSpPr txBox="1"/>
+          <p:nvPr/>
+        </p:nvSpPr>
+        <p:spPr>
+          <a:xfrm>
+            <a:off x="8503920" y="3639312"/>
+            <a:ext cx="3154680" cy="621792"/>
+          </a:xfrm>
+          <a:prstGeom prst="rect">
+            <a:avLst/>
+          </a:prstGeom>
+          <a:noFill/>
+        </p:spPr>
+        <p:txBody>
+          <a:bodyPr wrap="square" lIns="0" rIns="0" tIns="0" bIns="0">
+            <a:spAutoFit/>
+          </a:bodyPr>
+          <a:lstStyle/>
+          <a:p>
+            <a:pPr>
+              <a:spcAft>
+                <a:spcPts val="500"/>
+              </a:spcAft>
+              <a:defRPr sz="1500" b="1">
+                <a:solidFill>
+                  <a:srgbClr val="164F89"/>
+                </a:solidFill>
+                <a:latin typeface="Liberation Sans"/>
+              </a:defRPr>
+            </a:pPr>
+            <a:r>
+              <a:t>04  Benchmark framework &amp; progress</a:t>
+            </a:r>
+          </a:p>
+        </p:txBody>
+      </p:sp>
+      <p:sp>
+        <p:nvSpPr>
+          <p:cNvPr id="13" name="TextBox 12"/>
           <p:cNvSpPr txBox="1"/>
           <p:nvPr/>
         </p:nvSpPr>
@@ -8840,7 +8947,7 @@
       </p:sp>
       <p:sp>
         <p:nvSpPr>
-          <p:cNvPr id="9" name="TextBox 8"/>
+          <p:cNvPr id="14" name="TextBox 13"/>
           <p:cNvSpPr txBox="1"/>
           <p:nvPr/>
         </p:nvSpPr>
@@ -8872,7 +8979,7 @@
               </a:defRPr>
             </a:pPr>
             <a:r>
-              <a:t>18 / 22</a:t>
+              <a:t>18 / 23</a:t>
             </a:r>
           </a:p>
         </p:txBody>
@@ -9016,7 +9123,7 @@
               </a:defRPr>
             </a:pPr>
             <a:r>
-              <a:t>Benchmark Progress and Ongoing Validation</a:t>
+              <a:t>A Repeatable Scheduling Benchmark Framework</a:t>
             </a:r>
           </a:p>
         </p:txBody>
@@ -9055,14 +9162,14 @@
               </a:defRPr>
             </a:pPr>
             <a:r>
-              <a:t>The harness is available; testing and optimization continue across workload scenarios.</a:t>
+              <a:t>Generate scenarios, observe API events, and retain comparable measurements.</a:t>
             </a:r>
           </a:p>
         </p:txBody>
       </p:sp>
       <p:pic>
         <p:nvPicPr>
-          <p:cNvPr id="7" name="Picture 6" descr="19-benchmark-progress.png"/>
+          <p:cNvPr id="7" name="Picture 6" descr="19-benchmark-architecture.png"/>
           <p:cNvPicPr>
             <a:picLocks noChangeAspect="1"/>
           </p:cNvPicPr>
@@ -9157,7 +9264,7 @@
               </a:defRPr>
             </a:pPr>
             <a:r>
-              <a:t>19 / 22</a:t>
+              <a:t>19 / 23</a:t>
             </a:r>
           </a:p>
         </p:txBody>
@@ -9403,7 +9510,7 @@
               </a:defRPr>
             </a:pPr>
             <a:r>
-              <a:t>Cloud Native &amp; AI Infrastructure</a:t>
+              <a:t>AI Infrastructure Lead · Nunchux AI</a:t>
             </a:r>
           </a:p>
         </p:txBody>
@@ -9442,7 +9549,7 @@
               </a:defRPr>
             </a:pPr>
             <a:r>
-              <a:t>Open-source infrastructure</a:t>
+              <a:t>CNCF TOC Alternate (GB)</a:t>
             </a:r>
           </a:p>
           <a:p>
@@ -9458,7 +9565,7 @@
               </a:defRPr>
             </a:pPr>
             <a:r>
-              <a:t>Kubernetes and AI/ML platforms</a:t>
+              <a:t>Cloud native and AI infrastructure</a:t>
             </a:r>
           </a:p>
         </p:txBody>
@@ -9497,7 +9604,7 @@
               </a:defRPr>
             </a:pPr>
             <a:r>
-              <a:t>serverbooter.com</a:t>
+              <a:t>nunchux.ai · CNCF TOC</a:t>
             </a:r>
           </a:p>
         </p:txBody>
@@ -9771,7 +9878,7 @@
               </a:defRPr>
             </a:pPr>
             <a:r>
-              <a:t>02 / 22</a:t>
+              <a:t>02 / 23</a:t>
             </a:r>
           </a:p>
         </p:txBody>
@@ -9915,7 +10022,7 @@
               </a:defRPr>
             </a:pPr>
             <a:r>
-              <a:t>Benchmark Metrics: Latency and Throughput</a:t>
+              <a:t>Compare Schedulers on the Same Workload</a:t>
             </a:r>
           </a:p>
         </p:txBody>
@@ -9954,14 +10061,14 @@
               </a:defRPr>
             </a:pPr>
             <a:r>
-              <a:t>Separate scheduling delay, runtime readiness, and successful binding throughput.</a:t>
+              <a:t>Repeat controlled runs to understand throughput, latency, and placement tradeoffs.</a:t>
             </a:r>
           </a:p>
         </p:txBody>
       </p:sp>
       <p:pic>
         <p:nvPicPr>
-          <p:cNvPr id="7" name="Picture 6" descr="20-benchmark-measurement.png"/>
+          <p:cNvPr id="7" name="Picture 6" descr="20-benchmark-progress.png"/>
           <p:cNvPicPr>
             <a:picLocks noChangeAspect="1"/>
           </p:cNvPicPr>
@@ -10056,7 +10163,7 @@
               </a:defRPr>
             </a:pPr>
             <a:r>
-              <a:t>20 / 22</a:t>
+              <a:t>20 / 23</a:t>
             </a:r>
           </a:p>
         </p:txBody>
@@ -10200,7 +10307,7 @@
               </a:defRPr>
             </a:pPr>
             <a:r>
-              <a:t>What We Will Work On Next</a:t>
+              <a:t>Which Scenarios Fit Which Scheduler?</a:t>
             </a:r>
           </a:p>
         </p:txBody>
@@ -10239,14 +10346,14 @@
               </a:defRPr>
             </a:pPr>
             <a:r>
-              <a:t>Next steps in group placement, controller integration, and benchmarking.</a:t>
+              <a:t>Expand tests across arrival patterns, group structure, and network topology.</a:t>
             </a:r>
           </a:p>
         </p:txBody>
       </p:sp>
       <p:pic>
         <p:nvPicPr>
-          <p:cNvPr id="7" name="Picture 6" descr="21-takeaways.png"/>
+          <p:cNvPr id="7" name="Picture 6" descr="21-benchmark-measurement.png"/>
           <p:cNvPicPr>
             <a:picLocks noChangeAspect="1"/>
           </p:cNvPicPr>
@@ -10341,7 +10448,7 @@
               </a:defRPr>
             </a:pPr>
             <a:r>
-              <a:t>21 / 22</a:t>
+              <a:t>21 / 23</a:t>
             </a:r>
           </a:p>
         </p:txBody>
@@ -10446,7 +10553,7 @@
               </a:defRPr>
             </a:pPr>
             <a:r>
-              <a:t>MAINTAINER TRACK</a:t>
+              <a:t>BENCHMARK FRAMEWORK &amp; PROGRESS</a:t>
             </a:r>
           </a:p>
         </p:txBody>
@@ -10485,7 +10592,7 @@
               </a:defRPr>
             </a:pPr>
             <a:r>
-              <a:t>Questions &amp; Discussion</a:t>
+              <a:t>What We Will Work On Next</a:t>
             </a:r>
           </a:p>
         </p:txBody>
@@ -10524,14 +10631,14 @@
               </a:defRPr>
             </a:pPr>
             <a:r>
-              <a:t>Workload shapes, integration feedback, and reproducible observations are welcome.</a:t>
+              <a:t>Next steps in group placement, controller integration, and benchmarking.</a:t>
             </a:r>
           </a:p>
         </p:txBody>
       </p:sp>
       <p:pic>
         <p:nvPicPr>
-          <p:cNvPr id="7" name="Picture 6" descr="22-questions.png"/>
+          <p:cNvPr id="7" name="Picture 6" descr="22-takeaways.png"/>
           <p:cNvPicPr>
             <a:picLocks noChangeAspect="1"/>
           </p:cNvPicPr>
@@ -10626,7 +10733,292 @@
               </a:defRPr>
             </a:pPr>
             <a:r>
-              <a:t>22 / 22</a:t>
+              <a:t>22 / 23</a:t>
+            </a:r>
+          </a:p>
+        </p:txBody>
+      </p:sp>
+    </p:spTree>
+  </p:cSld>
+  <p:clrMapOvr>
+    <a:masterClrMapping/>
+  </p:clrMapOvr>
+</p:sld>
+</file>
+
+<file path=ppt/slides/slide23.xml><?xml version="1.0" encoding="utf-8"?>
+<p:sld xmlns:a="http://schemas.openxmlformats.org/drawingml/2006/main" xmlns:p="http://schemas.openxmlformats.org/presentationml/2006/main" xmlns:r="http://schemas.openxmlformats.org/officeDocument/2006/relationships">
+  <p:cSld>
+    <p:spTree>
+      <p:nvGrpSpPr>
+        <p:cNvPr id="1" name=""/>
+        <p:cNvGrpSpPr/>
+        <p:nvPr/>
+      </p:nvGrpSpPr>
+      <p:grpSpPr/>
+      <p:pic>
+        <p:nvPicPr>
+          <p:cNvPr id="2" name="Picture 1" descr="background.png"/>
+          <p:cNvPicPr>
+            <a:picLocks noChangeAspect="1"/>
+          </p:cNvPicPr>
+          <p:nvPr/>
+        </p:nvPicPr>
+        <p:blipFill>
+          <a:blip r:embed="rId2"/>
+          <a:stretch>
+            <a:fillRect/>
+          </a:stretch>
+        </p:blipFill>
+        <p:spPr>
+          <a:xfrm>
+            <a:off x="0" y="0"/>
+            <a:ext cx="12191999" cy="6858000"/>
+          </a:xfrm>
+          <a:prstGeom prst="rect">
+            <a:avLst/>
+          </a:prstGeom>
+        </p:spPr>
+      </p:pic>
+      <p:pic>
+        <p:nvPicPr>
+          <p:cNvPr id="3" name="Picture 2" descr="volcano-logo.png"/>
+          <p:cNvPicPr>
+            <a:picLocks noChangeAspect="1"/>
+          </p:cNvPicPr>
+          <p:nvPr/>
+        </p:nvPicPr>
+        <p:blipFill>
+          <a:blip r:embed="rId3"/>
+          <a:stretch>
+            <a:fillRect/>
+          </a:stretch>
+        </p:blipFill>
+        <p:spPr>
+          <a:xfrm>
+            <a:off x="9921240" y="292608"/>
+            <a:ext cx="1737360" cy="289560"/>
+          </a:xfrm>
+          <a:prstGeom prst="rect">
+            <a:avLst/>
+          </a:prstGeom>
+        </p:spPr>
+      </p:pic>
+      <p:sp>
+        <p:nvSpPr>
+          <p:cNvPr id="4" name="TextBox 3"/>
+          <p:cNvSpPr txBox="1"/>
+          <p:nvPr/>
+        </p:nvSpPr>
+        <p:spPr>
+          <a:xfrm>
+            <a:off x="457200" y="292608"/>
+            <a:ext cx="9144000" cy="256032"/>
+          </a:xfrm>
+          <a:prstGeom prst="rect">
+            <a:avLst/>
+          </a:prstGeom>
+          <a:noFill/>
+        </p:spPr>
+        <p:txBody>
+          <a:bodyPr wrap="square" lIns="0" rIns="0" tIns="0" bIns="0">
+            <a:spAutoFit/>
+          </a:bodyPr>
+          <a:lstStyle/>
+          <a:p>
+            <a:pPr>
+              <a:spcAft>
+                <a:spcPts val="500"/>
+              </a:spcAft>
+              <a:defRPr sz="1100" b="1">
+                <a:solidFill>
+                  <a:srgbClr val="164F89"/>
+                </a:solidFill>
+                <a:latin typeface="Liberation Sans"/>
+              </a:defRPr>
+            </a:pPr>
+            <a:r>
+              <a:t>MAINTAINER TRACK</a:t>
+            </a:r>
+          </a:p>
+        </p:txBody>
+      </p:sp>
+      <p:sp>
+        <p:nvSpPr>
+          <p:cNvPr id="5" name="TextBox 4"/>
+          <p:cNvSpPr txBox="1"/>
+          <p:nvPr/>
+        </p:nvSpPr>
+        <p:spPr>
+          <a:xfrm>
+            <a:off x="457200" y="804672"/>
+            <a:ext cx="11247120" cy="640080"/>
+          </a:xfrm>
+          <a:prstGeom prst="rect">
+            <a:avLst/>
+          </a:prstGeom>
+          <a:noFill/>
+        </p:spPr>
+        <p:txBody>
+          <a:bodyPr wrap="square" lIns="0" rIns="0" tIns="0" bIns="0">
+            <a:spAutoFit/>
+          </a:bodyPr>
+          <a:lstStyle/>
+          <a:p>
+            <a:pPr>
+              <a:spcAft>
+                <a:spcPts val="500"/>
+              </a:spcAft>
+              <a:defRPr sz="3100" b="1">
+                <a:solidFill>
+                  <a:srgbClr val="17283B"/>
+                </a:solidFill>
+                <a:latin typeface="Liberation Sans"/>
+              </a:defRPr>
+            </a:pPr>
+            <a:r>
+              <a:t>Questions &amp; Discussion</a:t>
+            </a:r>
+          </a:p>
+        </p:txBody>
+      </p:sp>
+      <p:sp>
+        <p:nvSpPr>
+          <p:cNvPr id="6" name="TextBox 5"/>
+          <p:cNvSpPr txBox="1"/>
+          <p:nvPr/>
+        </p:nvSpPr>
+        <p:spPr>
+          <a:xfrm>
+            <a:off x="475488" y="1435608"/>
+            <a:ext cx="11201400" cy="429768"/>
+          </a:xfrm>
+          <a:prstGeom prst="rect">
+            <a:avLst/>
+          </a:prstGeom>
+          <a:noFill/>
+        </p:spPr>
+        <p:txBody>
+          <a:bodyPr wrap="square" lIns="0" rIns="0" tIns="0" bIns="0">
+            <a:spAutoFit/>
+          </a:bodyPr>
+          <a:lstStyle/>
+          <a:p>
+            <a:pPr>
+              <a:spcAft>
+                <a:spcPts val="500"/>
+              </a:spcAft>
+              <a:defRPr sz="1700" b="0">
+                <a:solidFill>
+                  <a:srgbClr val="414F60"/>
+                </a:solidFill>
+                <a:latin typeface="Liberation Sans"/>
+              </a:defRPr>
+            </a:pPr>
+            <a:r>
+              <a:t>Workload shapes, integration feedback, and reproducible observations are welcome.</a:t>
+            </a:r>
+          </a:p>
+        </p:txBody>
+      </p:sp>
+      <p:pic>
+        <p:nvPicPr>
+          <p:cNvPr id="7" name="Picture 6" descr="23-questions.png"/>
+          <p:cNvPicPr>
+            <a:picLocks noChangeAspect="1"/>
+          </p:cNvPicPr>
+          <p:nvPr/>
+        </p:nvPicPr>
+        <p:blipFill>
+          <a:blip r:embed="rId4"/>
+          <a:stretch>
+            <a:fillRect/>
+          </a:stretch>
+        </p:blipFill>
+        <p:spPr>
+          <a:xfrm>
+            <a:off x="457200" y="1938528"/>
+            <a:ext cx="11277599" cy="4267200"/>
+          </a:xfrm>
+          <a:prstGeom prst="rect">
+            <a:avLst/>
+          </a:prstGeom>
+        </p:spPr>
+      </p:pic>
+      <p:sp>
+        <p:nvSpPr>
+          <p:cNvPr id="8" name="TextBox 7"/>
+          <p:cNvSpPr txBox="1"/>
+          <p:nvPr/>
+        </p:nvSpPr>
+        <p:spPr>
+          <a:xfrm>
+            <a:off x="475488" y="6519672"/>
+            <a:ext cx="10515600" cy="201168"/>
+          </a:xfrm>
+          <a:prstGeom prst="rect">
+            <a:avLst/>
+          </a:prstGeom>
+          <a:noFill/>
+        </p:spPr>
+        <p:txBody>
+          <a:bodyPr wrap="square" lIns="0" rIns="0" tIns="0" bIns="0">
+            <a:spAutoFit/>
+          </a:bodyPr>
+          <a:lstStyle/>
+          <a:p>
+            <a:pPr>
+              <a:spcAft>
+                <a:spcPts val="500"/>
+              </a:spcAft>
+              <a:defRPr sz="900" b="0">
+                <a:solidFill>
+                  <a:srgbClr val="414F60"/>
+                </a:solidFill>
+                <a:latin typeface="Liberation Sans"/>
+              </a:defRPr>
+            </a:pPr>
+            <a:r>
+              <a:t>Volcano  |  KubeCon + CloudNativeCon North America 2026</a:t>
+            </a:r>
+          </a:p>
+        </p:txBody>
+      </p:sp>
+      <p:sp>
+        <p:nvSpPr>
+          <p:cNvPr id="9" name="TextBox 8"/>
+          <p:cNvSpPr txBox="1"/>
+          <p:nvPr/>
+        </p:nvSpPr>
+        <p:spPr>
+          <a:xfrm>
+            <a:off x="11018520" y="6483096"/>
+            <a:ext cx="685800" cy="256032"/>
+          </a:xfrm>
+          <a:prstGeom prst="rect">
+            <a:avLst/>
+          </a:prstGeom>
+          <a:noFill/>
+        </p:spPr>
+        <p:txBody>
+          <a:bodyPr wrap="square" lIns="0" rIns="0" tIns="0" bIns="0">
+            <a:spAutoFit/>
+          </a:bodyPr>
+          <a:lstStyle/>
+          <a:p>
+            <a:pPr algn="r">
+              <a:spcAft>
+                <a:spcPts val="500"/>
+              </a:spcAft>
+              <a:defRPr sz="1100" b="0">
+                <a:solidFill>
+                  <a:srgbClr val="414F60"/>
+                </a:solidFill>
+                <a:latin typeface="Liberation Sans"/>
+              </a:defRPr>
+            </a:pPr>
+            <a:r>
+              <a:t>23 / 23</a:t>
             </a:r>
           </a:p>
         </p:txBody>
@@ -11121,7 +11513,7 @@
               </a:defRPr>
             </a:pPr>
             <a:r>
-              <a:t>03 / 22</a:t>
+              <a:t>03 / 23</a:t>
             </a:r>
           </a:p>
         </p:txBody>
@@ -11406,7 +11798,7 @@
               </a:defRPr>
             </a:pPr>
             <a:r>
-              <a:t>04 / 22</a:t>
+              <a:t>04 / 23</a:t>
             </a:r>
           </a:p>
         </p:txBody>
@@ -11691,7 +12083,7 @@
               </a:defRPr>
             </a:pPr>
             <a:r>
-              <a:t>05 / 22</a:t>
+              <a:t>05 / 23</a:t>
             </a:r>
           </a:p>
         </p:txBody>
@@ -11976,7 +12368,7 @@
               </a:defRPr>
             </a:pPr>
             <a:r>
-              <a:t>06 / 22</a:t>
+              <a:t>06 / 23</a:t>
             </a:r>
           </a:p>
         </p:txBody>
@@ -12487,7 +12879,7 @@
               </a:defRPr>
             </a:pPr>
             <a:r>
-              <a:t>07 / 22</a:t>
+              <a:t>07 / 23</a:t>
             </a:r>
           </a:p>
         </p:txBody>
@@ -12772,7 +13164,7 @@
               </a:defRPr>
             </a:pPr>
             <a:r>
-              <a:t>08 / 22</a:t>
+              <a:t>08 / 23</a:t>
             </a:r>
           </a:p>
         </p:txBody>
@@ -13057,7 +13449,7 @@
               </a:defRPr>
             </a:pPr>
             <a:r>
-              <a:t>09 / 22</a:t>
+              <a:t>09 / 23</a:t>
             </a:r>
           </a:p>
         </p:txBody>

</xml_diff>